<commit_message>
messy cleanup: attempt at sst and altprey model failed
</commit_message>
<xml_diff>
--- a/Rcode_for_paper/tables draft 1.pptx
+++ b/Rcode_for_paper/tables draft 1.pptx
@@ -269,7 +269,7 @@
           <a:p>
             <a:fld id="{83F55336-C41E-4230-B675-54A32B2176D1}" type="datetimeFigureOut">
               <a:rPr lang="en-US" smtClean="0"/>
-              <a:t>9/11/2026</a:t>
+              <a:t>9/14/2026</a:t>
             </a:fld>
             <a:endParaRPr lang="en-US"/>
           </a:p>
@@ -467,7 +467,7 @@
           <a:p>
             <a:fld id="{83F55336-C41E-4230-B675-54A32B2176D1}" type="datetimeFigureOut">
               <a:rPr lang="en-US" smtClean="0"/>
-              <a:t>9/11/2026</a:t>
+              <a:t>9/14/2026</a:t>
             </a:fld>
             <a:endParaRPr lang="en-US"/>
           </a:p>
@@ -675,7 +675,7 @@
           <a:p>
             <a:fld id="{83F55336-C41E-4230-B675-54A32B2176D1}" type="datetimeFigureOut">
               <a:rPr lang="en-US" smtClean="0"/>
-              <a:t>9/11/2026</a:t>
+              <a:t>9/14/2026</a:t>
             </a:fld>
             <a:endParaRPr lang="en-US"/>
           </a:p>
@@ -873,7 +873,7 @@
           <a:p>
             <a:fld id="{83F55336-C41E-4230-B675-54A32B2176D1}" type="datetimeFigureOut">
               <a:rPr lang="en-US" smtClean="0"/>
-              <a:t>9/11/2026</a:t>
+              <a:t>9/14/2026</a:t>
             </a:fld>
             <a:endParaRPr lang="en-US"/>
           </a:p>
@@ -1148,7 +1148,7 @@
           <a:p>
             <a:fld id="{83F55336-C41E-4230-B675-54A32B2176D1}" type="datetimeFigureOut">
               <a:rPr lang="en-US" smtClean="0"/>
-              <a:t>9/11/2026</a:t>
+              <a:t>9/14/2026</a:t>
             </a:fld>
             <a:endParaRPr lang="en-US"/>
           </a:p>
@@ -1413,7 +1413,7 @@
           <a:p>
             <a:fld id="{83F55336-C41E-4230-B675-54A32B2176D1}" type="datetimeFigureOut">
               <a:rPr lang="en-US" smtClean="0"/>
-              <a:t>9/11/2026</a:t>
+              <a:t>9/14/2026</a:t>
             </a:fld>
             <a:endParaRPr lang="en-US"/>
           </a:p>
@@ -1825,7 +1825,7 @@
           <a:p>
             <a:fld id="{83F55336-C41E-4230-B675-54A32B2176D1}" type="datetimeFigureOut">
               <a:rPr lang="en-US" smtClean="0"/>
-              <a:t>9/11/2026</a:t>
+              <a:t>9/14/2026</a:t>
             </a:fld>
             <a:endParaRPr lang="en-US"/>
           </a:p>
@@ -1966,7 +1966,7 @@
           <a:p>
             <a:fld id="{83F55336-C41E-4230-B675-54A32B2176D1}" type="datetimeFigureOut">
               <a:rPr lang="en-US" smtClean="0"/>
-              <a:t>9/11/2026</a:t>
+              <a:t>9/14/2026</a:t>
             </a:fld>
             <a:endParaRPr lang="en-US"/>
           </a:p>
@@ -2079,7 +2079,7 @@
           <a:p>
             <a:fld id="{83F55336-C41E-4230-B675-54A32B2176D1}" type="datetimeFigureOut">
               <a:rPr lang="en-US" smtClean="0"/>
-              <a:t>9/11/2026</a:t>
+              <a:t>9/14/2026</a:t>
             </a:fld>
             <a:endParaRPr lang="en-US"/>
           </a:p>
@@ -2390,7 +2390,7 @@
           <a:p>
             <a:fld id="{83F55336-C41E-4230-B675-54A32B2176D1}" type="datetimeFigureOut">
               <a:rPr lang="en-US" smtClean="0"/>
-              <a:t>9/11/2026</a:t>
+              <a:t>9/14/2026</a:t>
             </a:fld>
             <a:endParaRPr lang="en-US"/>
           </a:p>
@@ -2678,7 +2678,7 @@
           <a:p>
             <a:fld id="{83F55336-C41E-4230-B675-54A32B2176D1}" type="datetimeFigureOut">
               <a:rPr lang="en-US" smtClean="0"/>
-              <a:t>9/11/2026</a:t>
+              <a:t>9/14/2026</a:t>
             </a:fld>
             <a:endParaRPr lang="en-US"/>
           </a:p>
@@ -2919,7 +2919,7 @@
           <a:p>
             <a:fld id="{83F55336-C41E-4230-B675-54A32B2176D1}" type="datetimeFigureOut">
               <a:rPr lang="en-US" smtClean="0"/>
-              <a:t>9/11/2026</a:t>
+              <a:t>9/14/2026</a:t>
             </a:fld>
             <a:endParaRPr lang="en-US"/>
           </a:p>
@@ -3619,6 +3619,36 @@
           <a:chExt cx="0" cy="0"/>
         </a:xfrm>
       </p:grpSpPr>
+      <p:pic>
+        <p:nvPicPr>
+          <p:cNvPr id="3" name="Picture 2">
+            <a:extLst>
+              <a:ext uri="{FF2B5EF4-FFF2-40B4-BE49-F238E27FC236}">
+                <a16:creationId xmlns:a16="http://schemas.microsoft.com/office/drawing/2014/main" id="{016201F5-32D0-4C73-B0E3-9721B2830C09}"/>
+              </a:ext>
+            </a:extLst>
+          </p:cNvPr>
+          <p:cNvPicPr>
+            <a:picLocks noChangeAspect="1"/>
+          </p:cNvPicPr>
+          <p:nvPr/>
+        </p:nvPicPr>
+        <p:blipFill>
+          <a:blip r:embed="rId2"/>
+          <a:stretch>
+            <a:fillRect/>
+          </a:stretch>
+        </p:blipFill>
+        <p:spPr>
+          <a:xfrm>
+            <a:off x="1292679" y="1020588"/>
+            <a:ext cx="4250028" cy="3200400"/>
+          </a:xfrm>
+          <a:prstGeom prst="rect">
+            <a:avLst/>
+          </a:prstGeom>
+        </p:spPr>
+      </p:pic>
     </p:spTree>
     <p:extLst>
       <p:ext uri="{BB962C8B-B14F-4D97-AF65-F5344CB8AC3E}">
@@ -5015,6 +5045,112 @@
           <a:chExt cx="0" cy="0"/>
         </a:xfrm>
       </p:grpSpPr>
+      <p:pic>
+        <p:nvPicPr>
+          <p:cNvPr id="3" name="Picture 2">
+            <a:extLst>
+              <a:ext uri="{FF2B5EF4-FFF2-40B4-BE49-F238E27FC236}">
+                <a16:creationId xmlns:a16="http://schemas.microsoft.com/office/drawing/2014/main" id="{C11DFF7C-8DF3-4D82-8D8F-3224BE4C6CB0}"/>
+              </a:ext>
+            </a:extLst>
+          </p:cNvPr>
+          <p:cNvPicPr>
+            <a:picLocks noChangeAspect="1"/>
+          </p:cNvPicPr>
+          <p:nvPr/>
+        </p:nvPicPr>
+        <p:blipFill>
+          <a:blip r:embed="rId2"/>
+          <a:stretch>
+            <a:fillRect/>
+          </a:stretch>
+        </p:blipFill>
+        <p:spPr>
+          <a:xfrm>
+            <a:off x="892603" y="648285"/>
+            <a:ext cx="6053070" cy="3567448"/>
+          </a:xfrm>
+          <a:prstGeom prst="rect">
+            <a:avLst/>
+          </a:prstGeom>
+        </p:spPr>
+      </p:pic>
+      <p:sp>
+        <p:nvSpPr>
+          <p:cNvPr id="5" name="TextBox 4">
+            <a:extLst>
+              <a:ext uri="{FF2B5EF4-FFF2-40B4-BE49-F238E27FC236}">
+                <a16:creationId xmlns:a16="http://schemas.microsoft.com/office/drawing/2014/main" id="{7E2B83A9-3907-42A0-912C-AFD43AD40151}"/>
+              </a:ext>
+            </a:extLst>
+          </p:cNvPr>
+          <p:cNvSpPr txBox="1"/>
+          <p:nvPr/>
+        </p:nvSpPr>
+        <p:spPr>
+          <a:xfrm>
+            <a:off x="3048492" y="1860815"/>
+            <a:ext cx="6096982" cy="3139321"/>
+          </a:xfrm>
+          <a:prstGeom prst="rect">
+            <a:avLst/>
+          </a:prstGeom>
+          <a:noFill/>
+        </p:spPr>
+        <p:txBody>
+          <a:bodyPr wrap="square">
+            <a:spAutoFit/>
+          </a:bodyPr>
+          <a:lstStyle/>
+          <a:p>
+            <a:r>
+              <a:rPr lang="en-US" sz="1800" b="1" i="1" u="none" strike="noStrike" baseline="0" dirty="0">
+                <a:solidFill>
+                  <a:srgbClr val="000000"/>
+                </a:solidFill>
+                <a:latin typeface="Times New Roman" panose="02020603050405020304" pitchFamily="18" charset="0"/>
+              </a:rPr>
+              <a:t>2024 Return </a:t>
+            </a:r>
+            <a:endParaRPr lang="en-US" sz="1800" b="0" i="0" u="none" strike="noStrike" baseline="0" dirty="0">
+              <a:solidFill>
+                <a:srgbClr val="000000"/>
+              </a:solidFill>
+              <a:latin typeface="Times New Roman" panose="02020603050405020304" pitchFamily="18" charset="0"/>
+            </a:endParaRPr>
+          </a:p>
+          <a:p>
+            <a:r>
+              <a:rPr lang="en-US" sz="1800" b="0" i="0" u="none" strike="noStrike" baseline="0" dirty="0">
+                <a:solidFill>
+                  <a:srgbClr val="000000"/>
+                </a:solidFill>
+                <a:latin typeface="Times New Roman" panose="02020603050405020304" pitchFamily="18" charset="0"/>
+              </a:rPr>
+              <a:t>The 2024 upriver spring Chinook return to the Columbia River totaled 116,332 adults (Tables 1 and 5) and consisted of 101,171 Age-4 fish, 14,942 Age-5 fish, and 215 Age-6 fish. The return included 70,743 (10,514 wild) adult Snake River spring/summer Chinook and 18,224 (1,609 wild) adult upper Columbia spring Chinook. The remainder of the run was destined for tributaries in the mid-Columbia area. The 2024 upriver spring Chinook return was 96% of the preseason forecast of 121,000 fish and 76% the recent 10-year average (2014–2023) of 152,289 adults. The 2024 return ranked 21</a:t>
+            </a:r>
+            <a:r>
+              <a:rPr lang="en-US" sz="1100" b="0" i="0" u="none" strike="noStrike" baseline="0" dirty="0">
+                <a:solidFill>
+                  <a:srgbClr val="000000"/>
+                </a:solidFill>
+                <a:latin typeface="Times New Roman" panose="02020603050405020304" pitchFamily="18" charset="0"/>
+              </a:rPr>
+              <a:t>st </a:t>
+            </a:r>
+            <a:r>
+              <a:rPr lang="en-US" sz="1800" b="0" i="0" u="none" strike="noStrike" baseline="0" dirty="0">
+                <a:solidFill>
+                  <a:srgbClr val="000000"/>
+                </a:solidFill>
+                <a:latin typeface="Times New Roman" panose="02020603050405020304" pitchFamily="18" charset="0"/>
+              </a:rPr>
+              <a:t>out of all returns since 1980. </a:t>
+            </a:r>
+            <a:endParaRPr lang="en-US" dirty="0"/>
+          </a:p>
+        </p:txBody>
+      </p:sp>
     </p:spTree>
     <p:extLst>
       <p:ext uri="{BB962C8B-B14F-4D97-AF65-F5344CB8AC3E}">

</xml_diff>

<commit_message>
minmax scaling try 1
</commit_message>
<xml_diff>
--- a/Rcode_for_paper/tables draft 1.pptx
+++ b/Rcode_for_paper/tables draft 1.pptx
@@ -13,9 +13,13 @@
     <p:sldId id="256" r:id="rId7"/>
     <p:sldId id="264" r:id="rId8"/>
     <p:sldId id="260" r:id="rId9"/>
-    <p:sldId id="266" r:id="rId10"/>
-    <p:sldId id="267" r:id="rId11"/>
-    <p:sldId id="265" r:id="rId12"/>
+    <p:sldId id="271" r:id="rId10"/>
+    <p:sldId id="269" r:id="rId11"/>
+    <p:sldId id="270" r:id="rId12"/>
+    <p:sldId id="266" r:id="rId13"/>
+    <p:sldId id="267" r:id="rId14"/>
+    <p:sldId id="265" r:id="rId15"/>
+    <p:sldId id="268" r:id="rId16"/>
   </p:sldIdLst>
   <p:sldSz cx="12192000" cy="6858000"/>
   <p:notesSz cx="6858000" cy="9144000"/>
@@ -269,7 +273,7 @@
           <a:p>
             <a:fld id="{83F55336-C41E-4230-B675-54A32B2176D1}" type="datetimeFigureOut">
               <a:rPr lang="en-US" smtClean="0"/>
-              <a:t>9/14/2026</a:t>
+              <a:t>9/21/2026</a:t>
             </a:fld>
             <a:endParaRPr lang="en-US"/>
           </a:p>
@@ -467,7 +471,7 @@
           <a:p>
             <a:fld id="{83F55336-C41E-4230-B675-54A32B2176D1}" type="datetimeFigureOut">
               <a:rPr lang="en-US" smtClean="0"/>
-              <a:t>9/14/2026</a:t>
+              <a:t>9/21/2026</a:t>
             </a:fld>
             <a:endParaRPr lang="en-US"/>
           </a:p>
@@ -675,7 +679,7 @@
           <a:p>
             <a:fld id="{83F55336-C41E-4230-B675-54A32B2176D1}" type="datetimeFigureOut">
               <a:rPr lang="en-US" smtClean="0"/>
-              <a:t>9/14/2026</a:t>
+              <a:t>9/21/2026</a:t>
             </a:fld>
             <a:endParaRPr lang="en-US"/>
           </a:p>
@@ -873,7 +877,7 @@
           <a:p>
             <a:fld id="{83F55336-C41E-4230-B675-54A32B2176D1}" type="datetimeFigureOut">
               <a:rPr lang="en-US" smtClean="0"/>
-              <a:t>9/14/2026</a:t>
+              <a:t>9/21/2026</a:t>
             </a:fld>
             <a:endParaRPr lang="en-US"/>
           </a:p>
@@ -1148,7 +1152,7 @@
           <a:p>
             <a:fld id="{83F55336-C41E-4230-B675-54A32B2176D1}" type="datetimeFigureOut">
               <a:rPr lang="en-US" smtClean="0"/>
-              <a:t>9/14/2026</a:t>
+              <a:t>9/21/2026</a:t>
             </a:fld>
             <a:endParaRPr lang="en-US"/>
           </a:p>
@@ -1413,7 +1417,7 @@
           <a:p>
             <a:fld id="{83F55336-C41E-4230-B675-54A32B2176D1}" type="datetimeFigureOut">
               <a:rPr lang="en-US" smtClean="0"/>
-              <a:t>9/14/2026</a:t>
+              <a:t>9/21/2026</a:t>
             </a:fld>
             <a:endParaRPr lang="en-US"/>
           </a:p>
@@ -1825,7 +1829,7 @@
           <a:p>
             <a:fld id="{83F55336-C41E-4230-B675-54A32B2176D1}" type="datetimeFigureOut">
               <a:rPr lang="en-US" smtClean="0"/>
-              <a:t>9/14/2026</a:t>
+              <a:t>9/21/2026</a:t>
             </a:fld>
             <a:endParaRPr lang="en-US"/>
           </a:p>
@@ -1966,7 +1970,7 @@
           <a:p>
             <a:fld id="{83F55336-C41E-4230-B675-54A32B2176D1}" type="datetimeFigureOut">
               <a:rPr lang="en-US" smtClean="0"/>
-              <a:t>9/14/2026</a:t>
+              <a:t>9/21/2026</a:t>
             </a:fld>
             <a:endParaRPr lang="en-US"/>
           </a:p>
@@ -2079,7 +2083,7 @@
           <a:p>
             <a:fld id="{83F55336-C41E-4230-B675-54A32B2176D1}" type="datetimeFigureOut">
               <a:rPr lang="en-US" smtClean="0"/>
-              <a:t>9/14/2026</a:t>
+              <a:t>9/21/2026</a:t>
             </a:fld>
             <a:endParaRPr lang="en-US"/>
           </a:p>
@@ -2390,7 +2394,7 @@
           <a:p>
             <a:fld id="{83F55336-C41E-4230-B675-54A32B2176D1}" type="datetimeFigureOut">
               <a:rPr lang="en-US" smtClean="0"/>
-              <a:t>9/14/2026</a:t>
+              <a:t>9/21/2026</a:t>
             </a:fld>
             <a:endParaRPr lang="en-US"/>
           </a:p>
@@ -2678,7 +2682,7 @@
           <a:p>
             <a:fld id="{83F55336-C41E-4230-B675-54A32B2176D1}" type="datetimeFigureOut">
               <a:rPr lang="en-US" smtClean="0"/>
-              <a:t>9/14/2026</a:t>
+              <a:t>9/21/2026</a:t>
             </a:fld>
             <a:endParaRPr lang="en-US"/>
           </a:p>
@@ -2919,7 +2923,7 @@
           <a:p>
             <a:fld id="{83F55336-C41E-4230-B675-54A32B2176D1}" type="datetimeFigureOut">
               <a:rPr lang="en-US" smtClean="0"/>
-              <a:t>9/14/2026</a:t>
+              <a:t>9/21/2026</a:t>
             </a:fld>
             <a:endParaRPr lang="en-US"/>
           </a:p>
@@ -3624,6 +3628,292 @@
           <p:cNvPr id="3" name="Picture 2">
             <a:extLst>
               <a:ext uri="{FF2B5EF4-FFF2-40B4-BE49-F238E27FC236}">
+                <a16:creationId xmlns:a16="http://schemas.microsoft.com/office/drawing/2014/main" id="{1ACD9E15-E480-455E-BB9A-6D0468BC320A}"/>
+              </a:ext>
+            </a:extLst>
+          </p:cNvPr>
+          <p:cNvPicPr>
+            <a:picLocks noChangeAspect="1"/>
+          </p:cNvPicPr>
+          <p:nvPr/>
+        </p:nvPicPr>
+        <p:blipFill>
+          <a:blip r:embed="rId2"/>
+          <a:stretch>
+            <a:fillRect/>
+          </a:stretch>
+        </p:blipFill>
+        <p:spPr>
+          <a:xfrm>
+            <a:off x="1164218" y="0"/>
+            <a:ext cx="9863564" cy="6858000"/>
+          </a:xfrm>
+          <a:prstGeom prst="rect">
+            <a:avLst/>
+          </a:prstGeom>
+        </p:spPr>
+      </p:pic>
+    </p:spTree>
+    <p:extLst>
+      <p:ext uri="{BB962C8B-B14F-4D97-AF65-F5344CB8AC3E}">
+        <p14:creationId xmlns:p14="http://schemas.microsoft.com/office/powerpoint/2010/main" val="397683966"/>
+      </p:ext>
+    </p:extLst>
+  </p:cSld>
+  <p:clrMapOvr>
+    <a:masterClrMapping/>
+  </p:clrMapOvr>
+</p:sld>
+</file>
+
+<file path=ppt/slides/slide11.xml><?xml version="1.0" encoding="utf-8"?>
+<p:sld xmlns:a="http://schemas.openxmlformats.org/drawingml/2006/main" xmlns:r="http://schemas.openxmlformats.org/officeDocument/2006/relationships" xmlns:p="http://schemas.openxmlformats.org/presentationml/2006/main">
+  <p:cSld>
+    <p:spTree>
+      <p:nvGrpSpPr>
+        <p:cNvPr id="1" name=""/>
+        <p:cNvGrpSpPr/>
+        <p:nvPr/>
+      </p:nvGrpSpPr>
+      <p:grpSpPr>
+        <a:xfrm>
+          <a:off x="0" y="0"/>
+          <a:ext cx="0" cy="0"/>
+          <a:chOff x="0" y="0"/>
+          <a:chExt cx="0" cy="0"/>
+        </a:xfrm>
+      </p:grpSpPr>
+      <p:pic>
+        <p:nvPicPr>
+          <p:cNvPr id="3" name="Picture 2">
+            <a:extLst>
+              <a:ext uri="{FF2B5EF4-FFF2-40B4-BE49-F238E27FC236}">
+                <a16:creationId xmlns:a16="http://schemas.microsoft.com/office/drawing/2014/main" id="{ACA94AE8-DCB1-40F2-BCB2-F471554DBDD8}"/>
+              </a:ext>
+            </a:extLst>
+          </p:cNvPr>
+          <p:cNvPicPr>
+            <a:picLocks noChangeAspect="1"/>
+          </p:cNvPicPr>
+          <p:nvPr/>
+        </p:nvPicPr>
+        <p:blipFill>
+          <a:blip r:embed="rId2"/>
+          <a:stretch>
+            <a:fillRect/>
+          </a:stretch>
+        </p:blipFill>
+        <p:spPr>
+          <a:xfrm>
+            <a:off x="232462" y="434080"/>
+            <a:ext cx="6439458" cy="5989839"/>
+          </a:xfrm>
+          <a:prstGeom prst="rect">
+            <a:avLst/>
+          </a:prstGeom>
+        </p:spPr>
+      </p:pic>
+      <p:pic>
+        <p:nvPicPr>
+          <p:cNvPr id="5" name="Picture 4">
+            <a:extLst>
+              <a:ext uri="{FF2B5EF4-FFF2-40B4-BE49-F238E27FC236}">
+                <a16:creationId xmlns:a16="http://schemas.microsoft.com/office/drawing/2014/main" id="{38DB53BD-C0C3-4AFB-A8E3-F336758C8FA5}"/>
+              </a:ext>
+            </a:extLst>
+          </p:cNvPr>
+          <p:cNvPicPr>
+            <a:picLocks noChangeAspect="1"/>
+          </p:cNvPicPr>
+          <p:nvPr/>
+        </p:nvPicPr>
+        <p:blipFill>
+          <a:blip r:embed="rId3"/>
+          <a:stretch>
+            <a:fillRect/>
+          </a:stretch>
+        </p:blipFill>
+        <p:spPr>
+          <a:xfrm>
+            <a:off x="6758592" y="3081129"/>
+            <a:ext cx="5433408" cy="3531715"/>
+          </a:xfrm>
+          <a:prstGeom prst="rect">
+            <a:avLst/>
+          </a:prstGeom>
+        </p:spPr>
+      </p:pic>
+    </p:spTree>
+    <p:extLst>
+      <p:ext uri="{BB962C8B-B14F-4D97-AF65-F5344CB8AC3E}">
+        <p14:creationId xmlns:p14="http://schemas.microsoft.com/office/powerpoint/2010/main" val="1170459036"/>
+      </p:ext>
+    </p:extLst>
+  </p:cSld>
+  <p:clrMapOvr>
+    <a:masterClrMapping/>
+  </p:clrMapOvr>
+</p:sld>
+</file>
+
+<file path=ppt/slides/slide12.xml><?xml version="1.0" encoding="utf-8"?>
+<p:sld xmlns:a="http://schemas.openxmlformats.org/drawingml/2006/main" xmlns:r="http://schemas.openxmlformats.org/officeDocument/2006/relationships" xmlns:p="http://schemas.openxmlformats.org/presentationml/2006/main">
+  <p:cSld>
+    <p:spTree>
+      <p:nvGrpSpPr>
+        <p:cNvPr id="1" name=""/>
+        <p:cNvGrpSpPr/>
+        <p:nvPr/>
+      </p:nvGrpSpPr>
+      <p:grpSpPr>
+        <a:xfrm>
+          <a:off x="0" y="0"/>
+          <a:ext cx="0" cy="0"/>
+          <a:chOff x="0" y="0"/>
+          <a:chExt cx="0" cy="0"/>
+        </a:xfrm>
+      </p:grpSpPr>
+      <p:pic>
+        <p:nvPicPr>
+          <p:cNvPr id="3" name="Picture 2">
+            <a:extLst>
+              <a:ext uri="{FF2B5EF4-FFF2-40B4-BE49-F238E27FC236}">
+                <a16:creationId xmlns:a16="http://schemas.microsoft.com/office/drawing/2014/main" id="{C11DFF7C-8DF3-4D82-8D8F-3224BE4C6CB0}"/>
+              </a:ext>
+            </a:extLst>
+          </p:cNvPr>
+          <p:cNvPicPr>
+            <a:picLocks noChangeAspect="1"/>
+          </p:cNvPicPr>
+          <p:nvPr/>
+        </p:nvPicPr>
+        <p:blipFill>
+          <a:blip r:embed="rId2"/>
+          <a:stretch>
+            <a:fillRect/>
+          </a:stretch>
+        </p:blipFill>
+        <p:spPr>
+          <a:xfrm>
+            <a:off x="892603" y="648285"/>
+            <a:ext cx="6053070" cy="3567448"/>
+          </a:xfrm>
+          <a:prstGeom prst="rect">
+            <a:avLst/>
+          </a:prstGeom>
+        </p:spPr>
+      </p:pic>
+      <p:sp>
+        <p:nvSpPr>
+          <p:cNvPr id="5" name="TextBox 4">
+            <a:extLst>
+              <a:ext uri="{FF2B5EF4-FFF2-40B4-BE49-F238E27FC236}">
+                <a16:creationId xmlns:a16="http://schemas.microsoft.com/office/drawing/2014/main" id="{7E2B83A9-3907-42A0-912C-AFD43AD40151}"/>
+              </a:ext>
+            </a:extLst>
+          </p:cNvPr>
+          <p:cNvSpPr txBox="1"/>
+          <p:nvPr/>
+        </p:nvSpPr>
+        <p:spPr>
+          <a:xfrm>
+            <a:off x="5875667" y="3120447"/>
+            <a:ext cx="6096982" cy="3139321"/>
+          </a:xfrm>
+          <a:prstGeom prst="rect">
+            <a:avLst/>
+          </a:prstGeom>
+          <a:noFill/>
+        </p:spPr>
+        <p:txBody>
+          <a:bodyPr wrap="square">
+            <a:spAutoFit/>
+          </a:bodyPr>
+          <a:lstStyle/>
+          <a:p>
+            <a:r>
+              <a:rPr lang="en-US" sz="1800" b="1" i="1" u="none" strike="noStrike" baseline="0" dirty="0">
+                <a:solidFill>
+                  <a:srgbClr val="000000"/>
+                </a:solidFill>
+                <a:latin typeface="Times New Roman" panose="02020603050405020304" pitchFamily="18" charset="0"/>
+              </a:rPr>
+              <a:t>2024 Return </a:t>
+            </a:r>
+            <a:endParaRPr lang="en-US" sz="1800" b="0" i="0" u="none" strike="noStrike" baseline="0" dirty="0">
+              <a:solidFill>
+                <a:srgbClr val="000000"/>
+              </a:solidFill>
+              <a:latin typeface="Times New Roman" panose="02020603050405020304" pitchFamily="18" charset="0"/>
+            </a:endParaRPr>
+          </a:p>
+          <a:p>
+            <a:r>
+              <a:rPr lang="en-US" sz="1800" b="0" i="0" u="none" strike="noStrike" baseline="0" dirty="0">
+                <a:solidFill>
+                  <a:srgbClr val="000000"/>
+                </a:solidFill>
+                <a:latin typeface="Times New Roman" panose="02020603050405020304" pitchFamily="18" charset="0"/>
+              </a:rPr>
+              <a:t>The 2024 upriver spring Chinook return to the Columbia River totaled 116,332 adults (Tables 1 and 5) and consisted of 101,171 Age-4 fish, 14,942 Age-5 fish, and 215 Age-6 fish. The return included 70,743 (10,514 wild) adult Snake River spring/summer Chinook and 18,224 (1,609 wild) adult upper Columbia spring Chinook. The remainder of the run was destined for tributaries in the mid-Columbia area. The 2024 upriver spring Chinook return was 96% of the preseason forecast of 121,000 fish and 76% the recent 10-year average (2014–2023) of 152,289 adults. The 2024 return ranked 21</a:t>
+            </a:r>
+            <a:r>
+              <a:rPr lang="en-US" sz="1100" b="0" i="0" u="none" strike="noStrike" baseline="0" dirty="0">
+                <a:solidFill>
+                  <a:srgbClr val="000000"/>
+                </a:solidFill>
+                <a:latin typeface="Times New Roman" panose="02020603050405020304" pitchFamily="18" charset="0"/>
+              </a:rPr>
+              <a:t>st </a:t>
+            </a:r>
+            <a:r>
+              <a:rPr lang="en-US" sz="1800" b="0" i="0" u="none" strike="noStrike" baseline="0" dirty="0">
+                <a:solidFill>
+                  <a:srgbClr val="000000"/>
+                </a:solidFill>
+                <a:latin typeface="Times New Roman" panose="02020603050405020304" pitchFamily="18" charset="0"/>
+              </a:rPr>
+              <a:t>out of all returns since 1980. </a:t>
+            </a:r>
+            <a:endParaRPr lang="en-US" dirty="0"/>
+          </a:p>
+        </p:txBody>
+      </p:sp>
+    </p:spTree>
+    <p:extLst>
+      <p:ext uri="{BB962C8B-B14F-4D97-AF65-F5344CB8AC3E}">
+        <p14:creationId xmlns:p14="http://schemas.microsoft.com/office/powerpoint/2010/main" val="1901397784"/>
+      </p:ext>
+    </p:extLst>
+  </p:cSld>
+  <p:clrMapOvr>
+    <a:masterClrMapping/>
+  </p:clrMapOvr>
+</p:sld>
+</file>
+
+<file path=ppt/slides/slide13.xml><?xml version="1.0" encoding="utf-8"?>
+<p:sld xmlns:a="http://schemas.openxmlformats.org/drawingml/2006/main" xmlns:r="http://schemas.openxmlformats.org/officeDocument/2006/relationships" xmlns:p="http://schemas.openxmlformats.org/presentationml/2006/main">
+  <p:cSld>
+    <p:spTree>
+      <p:nvGrpSpPr>
+        <p:cNvPr id="1" name=""/>
+        <p:cNvGrpSpPr/>
+        <p:nvPr/>
+      </p:nvGrpSpPr>
+      <p:grpSpPr>
+        <a:xfrm>
+          <a:off x="0" y="0"/>
+          <a:ext cx="0" cy="0"/>
+          <a:chOff x="0" y="0"/>
+          <a:chExt cx="0" cy="0"/>
+        </a:xfrm>
+      </p:grpSpPr>
+      <p:pic>
+        <p:nvPicPr>
+          <p:cNvPr id="3" name="Picture 2">
+            <a:extLst>
+              <a:ext uri="{FF2B5EF4-FFF2-40B4-BE49-F238E27FC236}">
                 <a16:creationId xmlns:a16="http://schemas.microsoft.com/office/drawing/2014/main" id="{016201F5-32D0-4C73-B0E3-9721B2830C09}"/>
               </a:ext>
             </a:extLst>
@@ -3662,7 +3952,7 @@
 </p:sld>
 </file>
 
-<file path=ppt/slides/slide11.xml><?xml version="1.0" encoding="utf-8"?>
+<file path=ppt/slides/slide14.xml><?xml version="1.0" encoding="utf-8"?>
 <p:sld xmlns:a="http://schemas.openxmlformats.org/drawingml/2006/main" xmlns:r="http://schemas.openxmlformats.org/officeDocument/2006/relationships" xmlns:p="http://schemas.openxmlformats.org/presentationml/2006/main">
   <p:cSld>
     <p:spTree>
@@ -3679,10 +3969,406 @@
           <a:chExt cx="0" cy="0"/>
         </a:xfrm>
       </p:grpSpPr>
+      <p:sp>
+        <p:nvSpPr>
+          <p:cNvPr id="2" name="Rectangle 1">
+            <a:extLst>
+              <a:ext uri="{FF2B5EF4-FFF2-40B4-BE49-F238E27FC236}">
+                <a16:creationId xmlns:a16="http://schemas.microsoft.com/office/drawing/2014/main" id="{81EDECCD-E380-4F20-BA37-663AEAFEC174}"/>
+              </a:ext>
+            </a:extLst>
+          </p:cNvPr>
+          <p:cNvSpPr>
+            <a:spLocks noChangeArrowheads="1"/>
+          </p:cNvSpPr>
+          <p:nvPr/>
+        </p:nvSpPr>
+        <p:spPr bwMode="auto">
+          <a:xfrm>
+            <a:off x="209550" y="651897"/>
+            <a:ext cx="9610725" cy="2677656"/>
+          </a:xfrm>
+          <a:prstGeom prst="rect">
+            <a:avLst/>
+          </a:prstGeom>
+          <a:noFill/>
+          <a:ln>
+            <a:noFill/>
+          </a:ln>
+          <a:effectLst/>
+          <a:extLst>
+            <a:ext uri="{909E8E84-426E-40DD-AFC4-6F175D3DCCD1}">
+              <a14:hiddenFill xmlns:a14="http://schemas.microsoft.com/office/drawing/2010/main">
+                <a:solidFill>
+                  <a:schemeClr val="accent1"/>
+                </a:solidFill>
+              </a14:hiddenFill>
+            </a:ext>
+            <a:ext uri="{91240B29-F687-4F45-9708-019B960494DF}">
+              <a14:hiddenLine xmlns:a14="http://schemas.microsoft.com/office/drawing/2010/main" w="9525">
+                <a:solidFill>
+                  <a:schemeClr val="tx1"/>
+                </a:solidFill>
+                <a:miter lim="800000"/>
+                <a:headEnd/>
+                <a:tailEnd/>
+              </a14:hiddenLine>
+            </a:ext>
+            <a:ext uri="{AF507438-7753-43E0-B8FC-AC1667EBCBE1}">
+              <a14:hiddenEffects xmlns:a14="http://schemas.microsoft.com/office/drawing/2010/main">
+                <a:effectLst>
+                  <a:outerShdw dist="35921" dir="2700000" algn="ctr" rotWithShape="0">
+                    <a:schemeClr val="bg2"/>
+                  </a:outerShdw>
+                </a:effectLst>
+              </a14:hiddenEffects>
+            </a:ext>
+          </a:extLst>
+        </p:spPr>
+        <p:txBody>
+          <a:bodyPr vert="horz" wrap="square" lIns="0" tIns="0" rIns="0" bIns="45720" numCol="1" anchor="ctr" anchorCtr="0" compatLnSpc="1">
+            <a:prstTxWarp prst="textNoShape">
+              <a:avLst/>
+            </a:prstTxWarp>
+            <a:spAutoFit/>
+          </a:bodyPr>
+          <a:lstStyle/>
+          <a:p>
+            <a:pPr marL="0" marR="0" lvl="0" indent="0" algn="l" defTabSz="914400" rtl="0" eaLnBrk="0" fontAlgn="base" latinLnBrk="0" hangingPunct="0">
+              <a:lnSpc>
+                <a:spcPct val="100000"/>
+              </a:lnSpc>
+              <a:spcBef>
+                <a:spcPct val="0"/>
+              </a:spcBef>
+              <a:spcAft>
+                <a:spcPct val="0"/>
+              </a:spcAft>
+              <a:buClrTx/>
+              <a:buSzTx/>
+              <a:buFontTx/>
+              <a:buNone/>
+              <a:tabLst/>
+            </a:pPr>
+            <a:r>
+              <a:rPr kumimoji="0" lang="en-US" altLang="en-US" sz="900" b="1" i="0" u="none" strike="noStrike" cap="none" normalizeH="0" baseline="0">
+                <a:ln>
+                  <a:noFill/>
+                </a:ln>
+                <a:solidFill>
+                  <a:schemeClr val="tx1"/>
+                </a:solidFill>
+                <a:effectLst/>
+                <a:latin typeface="Google Sans"/>
+              </a:rPr>
+              <a:t>How the Logistic Switching Model Works</a:t>
+            </a:r>
+          </a:p>
+          <a:p>
+            <a:pPr marL="0" marR="0" lvl="0" indent="0" algn="l" defTabSz="914400" rtl="0" eaLnBrk="0" fontAlgn="base" latinLnBrk="0" hangingPunct="0">
+              <a:lnSpc>
+                <a:spcPct val="100000"/>
+              </a:lnSpc>
+              <a:spcBef>
+                <a:spcPct val="0"/>
+              </a:spcBef>
+              <a:spcAft>
+                <a:spcPct val="0"/>
+              </a:spcAft>
+              <a:buClrTx/>
+              <a:buSzTx/>
+              <a:buFontTx/>
+              <a:buNone/>
+              <a:tabLst/>
+            </a:pPr>
+            <a:r>
+              <a:rPr kumimoji="0" lang="en-US" altLang="en-US" sz="800" b="0" i="0" u="none" strike="noStrike" cap="none" normalizeH="0" baseline="0">
+                <a:ln>
+                  <a:noFill/>
+                </a:ln>
+                <a:solidFill>
+                  <a:schemeClr val="tx1"/>
+                </a:solidFill>
+                <a:effectLst/>
+                <a:latin typeface="Google Sans Text"/>
+              </a:rPr>
+              <a:t>Rather than multiplying </a:t>
+            </a:r>
+            <a:r>
+              <a:rPr kumimoji="0" lang="en-US" altLang="en-US" sz="1800" b="0" i="0" u="none" strike="noStrike" cap="none" normalizeH="0" baseline="0">
+                <a:ln>
+                  <a:noFill/>
+                </a:ln>
+                <a:solidFill>
+                  <a:schemeClr val="tx1"/>
+                </a:solidFill>
+                <a:effectLst/>
+                <a:latin typeface="Google Sans Text"/>
+              </a:rPr>
+              <a:t>$Z$-scores directly, the alternate prey/temperature series $A$ is min-max normalized to $A_{\text{norm}} \in [0, 1]$. The effective predator impact $P_{\text{eff}}$ on $SAR$ is modeled as:</a:t>
+            </a:r>
+            <a:endParaRPr kumimoji="0" lang="en-US" altLang="en-US" sz="1800" b="0" i="0" u="none" strike="noStrike" cap="none" normalizeH="0" baseline="0">
+              <a:ln>
+                <a:noFill/>
+              </a:ln>
+              <a:solidFill>
+                <a:schemeClr val="tx1"/>
+              </a:solidFill>
+              <a:effectLst/>
+            </a:endParaRPr>
+          </a:p>
+          <a:p>
+            <a:pPr marL="0" marR="0" lvl="0" indent="0" algn="l" defTabSz="914400" rtl="0" eaLnBrk="0" fontAlgn="base" latinLnBrk="0" hangingPunct="0">
+              <a:lnSpc>
+                <a:spcPct val="100000"/>
+              </a:lnSpc>
+              <a:spcBef>
+                <a:spcPct val="0"/>
+              </a:spcBef>
+              <a:spcAft>
+                <a:spcPct val="0"/>
+              </a:spcAft>
+              <a:buClrTx/>
+              <a:buSzTx/>
+              <a:buFontTx/>
+              <a:buNone/>
+              <a:tabLst/>
+            </a:pPr>
+            <a:r>
+              <a:rPr kumimoji="0" lang="en-US" altLang="en-US" sz="1800" b="0" i="0" u="none" strike="noStrike" cap="none" normalizeH="0" baseline="0">
+                <a:ln>
+                  <a:noFill/>
+                </a:ln>
+                <a:solidFill>
+                  <a:schemeClr val="tx1"/>
+                </a:solidFill>
+                <a:effectLst/>
+                <a:latin typeface="Google Sans Text"/>
+              </a:rPr>
+              <a:t>$$P_{\text{eff}} = P \times \left(1 - \frac{w}{1 + e^{-\gamma (A_{\text{norm}} - 0.5)}}\right)$$</a:t>
+            </a:r>
+            <a:endParaRPr kumimoji="0" lang="en-US" altLang="en-US" sz="1800" b="0" i="0" u="none" strike="noStrike" cap="none" normalizeH="0" baseline="0">
+              <a:ln>
+                <a:noFill/>
+              </a:ln>
+              <a:solidFill>
+                <a:schemeClr val="tx1"/>
+              </a:solidFill>
+              <a:effectLst/>
+            </a:endParaRPr>
+          </a:p>
+          <a:p>
+            <a:pPr marL="0" marR="0" lvl="0" indent="0" algn="l" defTabSz="914400" rtl="0" eaLnBrk="0" fontAlgn="base" latinLnBrk="0" hangingPunct="0">
+              <a:lnSpc>
+                <a:spcPct val="100000"/>
+              </a:lnSpc>
+              <a:spcBef>
+                <a:spcPct val="0"/>
+              </a:spcBef>
+              <a:spcAft>
+                <a:spcPct val="0"/>
+              </a:spcAft>
+              <a:buClrTx/>
+              <a:buSzTx/>
+              <a:buFontTx/>
+              <a:buChar char="•"/>
+              <a:tabLst/>
+            </a:pPr>
+            <a:r>
+              <a:rPr kumimoji="0" lang="en-US" altLang="en-US" sz="1800" b="1" i="0" u="none" strike="noStrike" cap="none" normalizeH="0" baseline="0">
+                <a:ln>
+                  <a:noFill/>
+                </a:ln>
+                <a:solidFill>
+                  <a:schemeClr val="tx1"/>
+                </a:solidFill>
+                <a:effectLst/>
+                <a:latin typeface="Google Sans Text"/>
+              </a:rPr>
+              <a:t>$w \in [0, 1]$ (Attenuation Strength):</a:t>
+            </a:r>
+            <a:r>
+              <a:rPr kumimoji="0" lang="en-US" altLang="en-US" sz="1800" b="0" i="0" u="none" strike="noStrike" cap="none" normalizeH="0" baseline="0">
+                <a:ln>
+                  <a:noFill/>
+                </a:ln>
+                <a:solidFill>
+                  <a:schemeClr val="tx1"/>
+                </a:solidFill>
+                <a:effectLst/>
+                <a:latin typeface="Google Sans Text"/>
+              </a:rPr>
+              <a:t> Maximum proportion by which alternate prey/temperature buffers predation when $A$ is abundant (e.g., $w = 0.6 \implies 60\%$ reduction).</a:t>
+            </a:r>
+          </a:p>
+          <a:p>
+            <a:pPr marL="0" marR="0" lvl="0" indent="0" algn="l" defTabSz="914400" rtl="0" eaLnBrk="0" fontAlgn="base" latinLnBrk="0" hangingPunct="0">
+              <a:lnSpc>
+                <a:spcPct val="100000"/>
+              </a:lnSpc>
+              <a:spcBef>
+                <a:spcPct val="0"/>
+              </a:spcBef>
+              <a:spcAft>
+                <a:spcPct val="0"/>
+              </a:spcAft>
+              <a:buClrTx/>
+              <a:buSzTx/>
+              <a:buFontTx/>
+              <a:buChar char="•"/>
+              <a:tabLst/>
+            </a:pPr>
+            <a:r>
+              <a:rPr kumimoji="0" lang="en-US" altLang="en-US" sz="1800" b="1" i="0" u="none" strike="noStrike" cap="none" normalizeH="0" baseline="0">
+                <a:ln>
+                  <a:noFill/>
+                </a:ln>
+                <a:solidFill>
+                  <a:schemeClr val="tx1"/>
+                </a:solidFill>
+                <a:effectLst/>
+                <a:latin typeface="Google Sans Text"/>
+              </a:rPr>
+              <a:t>$\gamma \in [1, 10]$ (Switching Steepness):</a:t>
+            </a:r>
+            <a:r>
+              <a:rPr kumimoji="0" lang="en-US" altLang="en-US" sz="1800" b="0" i="0" u="none" strike="noStrike" cap="none" normalizeH="0" baseline="0">
+                <a:ln>
+                  <a:noFill/>
+                </a:ln>
+                <a:solidFill>
+                  <a:schemeClr val="tx1"/>
+                </a:solidFill>
+                <a:effectLst/>
+                <a:latin typeface="Google Sans Text"/>
+              </a:rPr>
+              <a:t> Controls how sharply predators switch away from salmon as alternate prey increases ($\gamma = 1 \implies$ gradual linear-like transition; $\gamma = 10 \implies$ sharp threshold switch).</a:t>
+            </a:r>
+          </a:p>
+          <a:p>
+            <a:pPr marL="0" marR="0" lvl="0" indent="0" algn="l" defTabSz="914400" rtl="0" eaLnBrk="0" fontAlgn="base" latinLnBrk="0" hangingPunct="0">
+              <a:lnSpc>
+                <a:spcPct val="100000"/>
+              </a:lnSpc>
+              <a:spcBef>
+                <a:spcPct val="0"/>
+              </a:spcBef>
+              <a:spcAft>
+                <a:spcPct val="0"/>
+              </a:spcAft>
+              <a:buClrTx/>
+              <a:buSzTx/>
+              <a:buFontTx/>
+              <a:buNone/>
+              <a:tabLst/>
+            </a:pPr>
+            <a:endParaRPr kumimoji="0" lang="en-US" altLang="en-US" sz="1800" b="0" i="0" u="none" strike="noStrike" cap="none" normalizeH="0" baseline="0">
+              <a:ln>
+                <a:noFill/>
+              </a:ln>
+              <a:solidFill>
+                <a:schemeClr val="tx1"/>
+              </a:solidFill>
+              <a:effectLst/>
+              <a:latin typeface="Arial" panose="020B0604020202020204" pitchFamily="34" charset="0"/>
+            </a:endParaRPr>
+          </a:p>
+        </p:txBody>
+      </p:sp>
+      <p:pic>
+        <p:nvPicPr>
+          <p:cNvPr id="4" name="Picture 3">
+            <a:extLst>
+              <a:ext uri="{FF2B5EF4-FFF2-40B4-BE49-F238E27FC236}">
+                <a16:creationId xmlns:a16="http://schemas.microsoft.com/office/drawing/2014/main" id="{8F935DF7-359B-4843-9E34-26635B91B2E5}"/>
+              </a:ext>
+            </a:extLst>
+          </p:cNvPr>
+          <p:cNvPicPr>
+            <a:picLocks noChangeAspect="1"/>
+          </p:cNvPicPr>
+          <p:nvPr/>
+        </p:nvPicPr>
+        <p:blipFill>
+          <a:blip r:embed="rId2"/>
+          <a:stretch>
+            <a:fillRect/>
+          </a:stretch>
+        </p:blipFill>
+        <p:spPr>
+          <a:xfrm>
+            <a:off x="2118757" y="1237944"/>
+            <a:ext cx="7954485" cy="4382112"/>
+          </a:xfrm>
+          <a:prstGeom prst="rect">
+            <a:avLst/>
+          </a:prstGeom>
+        </p:spPr>
+      </p:pic>
     </p:spTree>
     <p:extLst>
       <p:ext uri="{BB962C8B-B14F-4D97-AF65-F5344CB8AC3E}">
         <p14:creationId xmlns:p14="http://schemas.microsoft.com/office/powerpoint/2010/main" val="3777159218"/>
+      </p:ext>
+    </p:extLst>
+  </p:cSld>
+  <p:clrMapOvr>
+    <a:masterClrMapping/>
+  </p:clrMapOvr>
+</p:sld>
+</file>
+
+<file path=ppt/slides/slide15.xml><?xml version="1.0" encoding="utf-8"?>
+<p:sld xmlns:a="http://schemas.openxmlformats.org/drawingml/2006/main" xmlns:r="http://schemas.openxmlformats.org/officeDocument/2006/relationships" xmlns:p="http://schemas.openxmlformats.org/presentationml/2006/main">
+  <p:cSld>
+    <p:spTree>
+      <p:nvGrpSpPr>
+        <p:cNvPr id="1" name=""/>
+        <p:cNvGrpSpPr/>
+        <p:nvPr/>
+      </p:nvGrpSpPr>
+      <p:grpSpPr>
+        <a:xfrm>
+          <a:off x="0" y="0"/>
+          <a:ext cx="0" cy="0"/>
+          <a:chOff x="0" y="0"/>
+          <a:chExt cx="0" cy="0"/>
+        </a:xfrm>
+      </p:grpSpPr>
+      <p:pic>
+        <p:nvPicPr>
+          <p:cNvPr id="3" name="Picture 2">
+            <a:extLst>
+              <a:ext uri="{FF2B5EF4-FFF2-40B4-BE49-F238E27FC236}">
+                <a16:creationId xmlns:a16="http://schemas.microsoft.com/office/drawing/2014/main" id="{E902DD30-AC34-44A5-8F0B-558C67B09910}"/>
+              </a:ext>
+            </a:extLst>
+          </p:cNvPr>
+          <p:cNvPicPr>
+            <a:picLocks noChangeAspect="1"/>
+          </p:cNvPicPr>
+          <p:nvPr/>
+        </p:nvPicPr>
+        <p:blipFill>
+          <a:blip r:embed="rId2"/>
+          <a:stretch>
+            <a:fillRect/>
+          </a:stretch>
+        </p:blipFill>
+        <p:spPr>
+          <a:xfrm>
+            <a:off x="1928231" y="1109339"/>
+            <a:ext cx="8335538" cy="4639322"/>
+          </a:xfrm>
+          <a:prstGeom prst="rect">
+            <a:avLst/>
+          </a:prstGeom>
+        </p:spPr>
+      </p:pic>
+    </p:spTree>
+    <p:extLst>
+      <p:ext uri="{BB962C8B-B14F-4D97-AF65-F5344CB8AC3E}">
+        <p14:creationId xmlns:p14="http://schemas.microsoft.com/office/powerpoint/2010/main" val="744463467"/>
       </p:ext>
     </p:extLst>
   </p:cSld>
@@ -5007,7 +5693,7 @@
         </p:blipFill>
         <p:spPr>
           <a:xfrm>
-            <a:off x="643467" y="1425194"/>
+            <a:off x="683224" y="500855"/>
             <a:ext cx="10905066" cy="4007610"/>
           </a:xfrm>
           <a:prstGeom prst="rect">
@@ -5015,6 +5701,2199 @@
           </a:prstGeom>
         </p:spPr>
       </p:pic>
+      <p:graphicFrame>
+        <p:nvGraphicFramePr>
+          <p:cNvPr id="2" name="Table 1">
+            <a:extLst>
+              <a:ext uri="{FF2B5EF4-FFF2-40B4-BE49-F238E27FC236}">
+                <a16:creationId xmlns:a16="http://schemas.microsoft.com/office/drawing/2014/main" id="{B91A5FF5-BC57-45F2-8EF2-0CE6BB58A448}"/>
+              </a:ext>
+            </a:extLst>
+          </p:cNvPr>
+          <p:cNvGraphicFramePr>
+            <a:graphicFrameLocks noGrp="1"/>
+          </p:cNvGraphicFramePr>
+          <p:nvPr>
+            <p:extLst>
+              <p:ext uri="{D42A27DB-BD31-4B8C-83A1-F6EECF244321}">
+                <p14:modId xmlns:p14="http://schemas.microsoft.com/office/powerpoint/2010/main" val="1158154214"/>
+              </p:ext>
+            </p:extLst>
+          </p:nvPr>
+        </p:nvGraphicFramePr>
+        <p:xfrm>
+          <a:off x="669235" y="4855611"/>
+          <a:ext cx="10515601" cy="1542873"/>
+        </p:xfrm>
+        <a:graphic>
+          <a:graphicData uri="http://schemas.openxmlformats.org/drawingml/2006/table">
+            <a:tbl>
+              <a:tblPr>
+                <a:tableStyleId>{5C22544A-7EE6-4342-B048-85BDC9FD1C3A}</a:tableStyleId>
+              </a:tblPr>
+              <a:tblGrid>
+                <a:gridCol w="2658991">
+                  <a:extLst>
+                    <a:ext uri="{9D8B030D-6E8A-4147-A177-3AD203B41FA5}">
+                      <a16:colId xmlns:a16="http://schemas.microsoft.com/office/drawing/2014/main" val="3017393899"/>
+                    </a:ext>
+                  </a:extLst>
+                </a:gridCol>
+                <a:gridCol w="3129513">
+                  <a:extLst>
+                    <a:ext uri="{9D8B030D-6E8A-4147-A177-3AD203B41FA5}">
+                      <a16:colId xmlns:a16="http://schemas.microsoft.com/office/drawing/2014/main" val="1814453786"/>
+                    </a:ext>
+                  </a:extLst>
+                </a:gridCol>
+                <a:gridCol w="525233">
+                  <a:extLst>
+                    <a:ext uri="{9D8B030D-6E8A-4147-A177-3AD203B41FA5}">
+                      <a16:colId xmlns:a16="http://schemas.microsoft.com/office/drawing/2014/main" val="4006253691"/>
+                    </a:ext>
+                  </a:extLst>
+                </a:gridCol>
+                <a:gridCol w="525233">
+                  <a:extLst>
+                    <a:ext uri="{9D8B030D-6E8A-4147-A177-3AD203B41FA5}">
+                      <a16:colId xmlns:a16="http://schemas.microsoft.com/office/drawing/2014/main" val="78572986"/>
+                    </a:ext>
+                  </a:extLst>
+                </a:gridCol>
+                <a:gridCol w="525233">
+                  <a:extLst>
+                    <a:ext uri="{9D8B030D-6E8A-4147-A177-3AD203B41FA5}">
+                      <a16:colId xmlns:a16="http://schemas.microsoft.com/office/drawing/2014/main" val="73108253"/>
+                    </a:ext>
+                  </a:extLst>
+                </a:gridCol>
+                <a:gridCol w="525233">
+                  <a:extLst>
+                    <a:ext uri="{9D8B030D-6E8A-4147-A177-3AD203B41FA5}">
+                      <a16:colId xmlns:a16="http://schemas.microsoft.com/office/drawing/2014/main" val="3935394217"/>
+                    </a:ext>
+                  </a:extLst>
+                </a:gridCol>
+                <a:gridCol w="525233">
+                  <a:extLst>
+                    <a:ext uri="{9D8B030D-6E8A-4147-A177-3AD203B41FA5}">
+                      <a16:colId xmlns:a16="http://schemas.microsoft.com/office/drawing/2014/main" val="1388269684"/>
+                    </a:ext>
+                  </a:extLst>
+                </a:gridCol>
+                <a:gridCol w="525233">
+                  <a:extLst>
+                    <a:ext uri="{9D8B030D-6E8A-4147-A177-3AD203B41FA5}">
+                      <a16:colId xmlns:a16="http://schemas.microsoft.com/office/drawing/2014/main" val="420941006"/>
+                    </a:ext>
+                  </a:extLst>
+                </a:gridCol>
+                <a:gridCol w="525233">
+                  <a:extLst>
+                    <a:ext uri="{9D8B030D-6E8A-4147-A177-3AD203B41FA5}">
+                      <a16:colId xmlns:a16="http://schemas.microsoft.com/office/drawing/2014/main" val="2610667979"/>
+                    </a:ext>
+                  </a:extLst>
+                </a:gridCol>
+                <a:gridCol w="525233">
+                  <a:extLst>
+                    <a:ext uri="{9D8B030D-6E8A-4147-A177-3AD203B41FA5}">
+                      <a16:colId xmlns:a16="http://schemas.microsoft.com/office/drawing/2014/main" val="691600280"/>
+                    </a:ext>
+                  </a:extLst>
+                </a:gridCol>
+                <a:gridCol w="525233">
+                  <a:extLst>
+                    <a:ext uri="{9D8B030D-6E8A-4147-A177-3AD203B41FA5}">
+                      <a16:colId xmlns:a16="http://schemas.microsoft.com/office/drawing/2014/main" val="3630889673"/>
+                    </a:ext>
+                  </a:extLst>
+                </a:gridCol>
+              </a:tblGrid>
+              <a:tr h="439883">
+                <a:tc>
+                  <a:txBody>
+                    <a:bodyPr/>
+                    <a:lstStyle/>
+                    <a:p>
+                      <a:pPr algn="l" fontAlgn="b"/>
+                      <a:r>
+                        <a:rPr lang="en-US" sz="900" u="none" strike="noStrike">
+                          <a:effectLst/>
+                        </a:rPr>
+                        <a:t>predator</a:t>
+                      </a:r>
+                      <a:endParaRPr lang="en-US" sz="900" b="0" i="0" u="none" strike="noStrike">
+                        <a:solidFill>
+                          <a:srgbClr val="000000"/>
+                        </a:solidFill>
+                        <a:effectLst/>
+                        <a:latin typeface="Calibri" panose="020F0502020204030204" pitchFamily="34" charset="0"/>
+                      </a:endParaRPr>
+                    </a:p>
+                  </a:txBody>
+                  <a:tcPr marL="6565" marR="6565" marT="6565" marB="0" anchor="b"/>
+                </a:tc>
+                <a:tc>
+                  <a:txBody>
+                    <a:bodyPr/>
+                    <a:lstStyle/>
+                    <a:p>
+                      <a:pPr algn="l" fontAlgn="b"/>
+                      <a:r>
+                        <a:rPr lang="en-US" sz="900" u="none" strike="noStrike">
+                          <a:effectLst/>
+                        </a:rPr>
+                        <a:t>selected_prey</a:t>
+                      </a:r>
+                      <a:endParaRPr lang="en-US" sz="900" b="0" i="0" u="none" strike="noStrike">
+                        <a:solidFill>
+                          <a:srgbClr val="000000"/>
+                        </a:solidFill>
+                        <a:effectLst/>
+                        <a:latin typeface="Calibri" panose="020F0502020204030204" pitchFamily="34" charset="0"/>
+                      </a:endParaRPr>
+                    </a:p>
+                  </a:txBody>
+                  <a:tcPr marL="6565" marR="6565" marT="6565" marB="0" anchor="b"/>
+                </a:tc>
+                <a:tc>
+                  <a:txBody>
+                    <a:bodyPr/>
+                    <a:lstStyle/>
+                    <a:p>
+                      <a:pPr algn="l" fontAlgn="b"/>
+                      <a:r>
+                        <a:rPr lang="en-US" sz="900" u="none" strike="noStrike">
+                          <a:effectLst/>
+                        </a:rPr>
+                        <a:t>fitted_weights</a:t>
+                      </a:r>
+                      <a:endParaRPr lang="en-US" sz="900" b="0" i="0" u="none" strike="noStrike">
+                        <a:solidFill>
+                          <a:srgbClr val="000000"/>
+                        </a:solidFill>
+                        <a:effectLst/>
+                        <a:latin typeface="Calibri" panose="020F0502020204030204" pitchFamily="34" charset="0"/>
+                      </a:endParaRPr>
+                    </a:p>
+                  </a:txBody>
+                  <a:tcPr marL="6565" marR="6565" marT="6565" marB="0" anchor="b"/>
+                </a:tc>
+                <a:tc>
+                  <a:txBody>
+                    <a:bodyPr/>
+                    <a:lstStyle/>
+                    <a:p>
+                      <a:pPr algn="l" fontAlgn="b"/>
+                      <a:r>
+                        <a:rPr lang="en-US" sz="900" u="none" strike="noStrike">
+                          <a:effectLst/>
+                        </a:rPr>
+                        <a:t>beta_peff</a:t>
+                      </a:r>
+                      <a:endParaRPr lang="en-US" sz="900" b="0" i="0" u="none" strike="noStrike">
+                        <a:solidFill>
+                          <a:srgbClr val="000000"/>
+                        </a:solidFill>
+                        <a:effectLst/>
+                        <a:latin typeface="Calibri" panose="020F0502020204030204" pitchFamily="34" charset="0"/>
+                      </a:endParaRPr>
+                    </a:p>
+                  </a:txBody>
+                  <a:tcPr marL="6565" marR="6565" marT="6565" marB="0" anchor="b"/>
+                </a:tc>
+                <a:tc>
+                  <a:txBody>
+                    <a:bodyPr/>
+                    <a:lstStyle/>
+                    <a:p>
+                      <a:pPr algn="l" fontAlgn="b"/>
+                      <a:r>
+                        <a:rPr lang="en-US" sz="900" u="none" strike="noStrike">
+                          <a:effectLst/>
+                        </a:rPr>
+                        <a:t>pvalue</a:t>
+                      </a:r>
+                      <a:endParaRPr lang="en-US" sz="900" b="0" i="0" u="none" strike="noStrike">
+                        <a:solidFill>
+                          <a:srgbClr val="000000"/>
+                        </a:solidFill>
+                        <a:effectLst/>
+                        <a:latin typeface="Calibri" panose="020F0502020204030204" pitchFamily="34" charset="0"/>
+                      </a:endParaRPr>
+                    </a:p>
+                  </a:txBody>
+                  <a:tcPr marL="6565" marR="6565" marT="6565" marB="0" anchor="b"/>
+                </a:tc>
+                <a:tc>
+                  <a:txBody>
+                    <a:bodyPr/>
+                    <a:lstStyle/>
+                    <a:p>
+                      <a:pPr algn="l" fontAlgn="b"/>
+                      <a:r>
+                        <a:rPr lang="en-US" sz="900" u="none" strike="noStrike">
+                          <a:effectLst/>
+                        </a:rPr>
+                        <a:t>std_eff_beta</a:t>
+                      </a:r>
+                      <a:endParaRPr lang="en-US" sz="900" b="0" i="0" u="none" strike="noStrike">
+                        <a:solidFill>
+                          <a:srgbClr val="000000"/>
+                        </a:solidFill>
+                        <a:effectLst/>
+                        <a:latin typeface="Calibri" panose="020F0502020204030204" pitchFamily="34" charset="0"/>
+                      </a:endParaRPr>
+                    </a:p>
+                  </a:txBody>
+                  <a:tcPr marL="6565" marR="6565" marT="6565" marB="0" anchor="b"/>
+                </a:tc>
+                <a:tc>
+                  <a:txBody>
+                    <a:bodyPr/>
+                    <a:lstStyle/>
+                    <a:p>
+                      <a:pPr algn="l" fontAlgn="b"/>
+                      <a:r>
+                        <a:rPr lang="en-US" sz="900" u="none" strike="noStrike">
+                          <a:effectLst/>
+                        </a:rPr>
+                        <a:t>mean_net_impact</a:t>
+                      </a:r>
+                      <a:endParaRPr lang="en-US" sz="900" b="0" i="0" u="none" strike="noStrike">
+                        <a:solidFill>
+                          <a:srgbClr val="000000"/>
+                        </a:solidFill>
+                        <a:effectLst/>
+                        <a:latin typeface="Calibri" panose="020F0502020204030204" pitchFamily="34" charset="0"/>
+                      </a:endParaRPr>
+                    </a:p>
+                  </a:txBody>
+                  <a:tcPr marL="6565" marR="6565" marT="6565" marB="0" anchor="b"/>
+                </a:tc>
+                <a:tc>
+                  <a:txBody>
+                    <a:bodyPr/>
+                    <a:lstStyle/>
+                    <a:p>
+                      <a:pPr algn="l" fontAlgn="b"/>
+                      <a:r>
+                        <a:rPr lang="en-US" sz="900" u="none" strike="noStrike">
+                          <a:effectLst/>
+                        </a:rPr>
+                        <a:t>realized_damping_pct</a:t>
+                      </a:r>
+                      <a:endParaRPr lang="en-US" sz="900" b="0" i="0" u="none" strike="noStrike">
+                        <a:solidFill>
+                          <a:srgbClr val="000000"/>
+                        </a:solidFill>
+                        <a:effectLst/>
+                        <a:latin typeface="Calibri" panose="020F0502020204030204" pitchFamily="34" charset="0"/>
+                      </a:endParaRPr>
+                    </a:p>
+                  </a:txBody>
+                  <a:tcPr marL="6565" marR="6565" marT="6565" marB="0" anchor="b"/>
+                </a:tc>
+                <a:tc>
+                  <a:txBody>
+                    <a:bodyPr/>
+                    <a:lstStyle/>
+                    <a:p>
+                      <a:pPr algn="l" fontAlgn="b"/>
+                      <a:r>
+                        <a:rPr lang="en-US" sz="900" u="none" strike="noStrike">
+                          <a:effectLst/>
+                        </a:rPr>
+                        <a:t>aic</a:t>
+                      </a:r>
+                      <a:endParaRPr lang="en-US" sz="900" b="0" i="0" u="none" strike="noStrike">
+                        <a:solidFill>
+                          <a:srgbClr val="000000"/>
+                        </a:solidFill>
+                        <a:effectLst/>
+                        <a:latin typeface="Calibri" panose="020F0502020204030204" pitchFamily="34" charset="0"/>
+                      </a:endParaRPr>
+                    </a:p>
+                  </a:txBody>
+                  <a:tcPr marL="6565" marR="6565" marT="6565" marB="0" anchor="b"/>
+                </a:tc>
+                <a:tc>
+                  <a:txBody>
+                    <a:bodyPr/>
+                    <a:lstStyle/>
+                    <a:p>
+                      <a:pPr algn="l" fontAlgn="b"/>
+                      <a:r>
+                        <a:rPr lang="en-US" sz="900" u="none" strike="noStrike">
+                          <a:effectLst/>
+                        </a:rPr>
+                        <a:t>base_aic</a:t>
+                      </a:r>
+                      <a:endParaRPr lang="en-US" sz="900" b="0" i="0" u="none" strike="noStrike">
+                        <a:solidFill>
+                          <a:srgbClr val="000000"/>
+                        </a:solidFill>
+                        <a:effectLst/>
+                        <a:latin typeface="Calibri" panose="020F0502020204030204" pitchFamily="34" charset="0"/>
+                      </a:endParaRPr>
+                    </a:p>
+                  </a:txBody>
+                  <a:tcPr marL="6565" marR="6565" marT="6565" marB="0" anchor="b"/>
+                </a:tc>
+                <a:tc>
+                  <a:txBody>
+                    <a:bodyPr/>
+                    <a:lstStyle/>
+                    <a:p>
+                      <a:pPr algn="l" fontAlgn="b"/>
+                      <a:r>
+                        <a:rPr lang="en-US" sz="900" u="none" strike="noStrike">
+                          <a:effectLst/>
+                        </a:rPr>
+                        <a:t>delta_aic</a:t>
+                      </a:r>
+                      <a:endParaRPr lang="en-US" sz="900" b="0" i="0" u="none" strike="noStrike">
+                        <a:solidFill>
+                          <a:srgbClr val="000000"/>
+                        </a:solidFill>
+                        <a:effectLst/>
+                        <a:latin typeface="Calibri" panose="020F0502020204030204" pitchFamily="34" charset="0"/>
+                      </a:endParaRPr>
+                    </a:p>
+                  </a:txBody>
+                  <a:tcPr marL="6565" marR="6565" marT="6565" marB="0" anchor="b"/>
+                </a:tc>
+                <a:extLst>
+                  <a:ext uri="{0D108BD9-81ED-4DB2-BD59-A6C34878D82A}">
+                    <a16:rowId xmlns:a16="http://schemas.microsoft.com/office/drawing/2014/main" val="1691292741"/>
+                  </a:ext>
+                </a:extLst>
+              </a:tr>
+              <a:tr h="157570">
+                <a:tc>
+                  <a:txBody>
+                    <a:bodyPr/>
+                    <a:lstStyle/>
+                    <a:p>
+                      <a:pPr algn="l" fontAlgn="b"/>
+                      <a:r>
+                        <a:rPr lang="en-US" sz="900" u="none" strike="noStrike">
+                          <a:effectLst/>
+                        </a:rPr>
+                        <a:t>&lt;chr&gt;</a:t>
+                      </a:r>
+                      <a:endParaRPr lang="en-US" sz="900" b="0" i="0" u="none" strike="noStrike">
+                        <a:solidFill>
+                          <a:srgbClr val="000000"/>
+                        </a:solidFill>
+                        <a:effectLst/>
+                        <a:latin typeface="Calibri" panose="020F0502020204030204" pitchFamily="34" charset="0"/>
+                      </a:endParaRPr>
+                    </a:p>
+                  </a:txBody>
+                  <a:tcPr marL="6565" marR="6565" marT="6565" marB="0" anchor="b"/>
+                </a:tc>
+                <a:tc>
+                  <a:txBody>
+                    <a:bodyPr/>
+                    <a:lstStyle/>
+                    <a:p>
+                      <a:pPr algn="l" fontAlgn="b"/>
+                      <a:r>
+                        <a:rPr lang="en-US" sz="900" u="none" strike="noStrike">
+                          <a:effectLst/>
+                        </a:rPr>
+                        <a:t>&lt;chr&gt;</a:t>
+                      </a:r>
+                      <a:endParaRPr lang="en-US" sz="900" b="0" i="0" u="none" strike="noStrike">
+                        <a:solidFill>
+                          <a:srgbClr val="000000"/>
+                        </a:solidFill>
+                        <a:effectLst/>
+                        <a:latin typeface="Calibri" panose="020F0502020204030204" pitchFamily="34" charset="0"/>
+                      </a:endParaRPr>
+                    </a:p>
+                  </a:txBody>
+                  <a:tcPr marL="6565" marR="6565" marT="6565" marB="0" anchor="b"/>
+                </a:tc>
+                <a:tc>
+                  <a:txBody>
+                    <a:bodyPr/>
+                    <a:lstStyle/>
+                    <a:p>
+                      <a:pPr algn="l" fontAlgn="b"/>
+                      <a:r>
+                        <a:rPr lang="en-US" sz="900" u="none" strike="noStrike">
+                          <a:effectLst/>
+                        </a:rPr>
+                        <a:t>&lt;chr&gt;</a:t>
+                      </a:r>
+                      <a:endParaRPr lang="en-US" sz="900" b="0" i="0" u="none" strike="noStrike">
+                        <a:solidFill>
+                          <a:srgbClr val="000000"/>
+                        </a:solidFill>
+                        <a:effectLst/>
+                        <a:latin typeface="Calibri" panose="020F0502020204030204" pitchFamily="34" charset="0"/>
+                      </a:endParaRPr>
+                    </a:p>
+                  </a:txBody>
+                  <a:tcPr marL="6565" marR="6565" marT="6565" marB="0" anchor="b"/>
+                </a:tc>
+                <a:tc>
+                  <a:txBody>
+                    <a:bodyPr/>
+                    <a:lstStyle/>
+                    <a:p>
+                      <a:pPr algn="l" fontAlgn="b"/>
+                      <a:r>
+                        <a:rPr lang="en-US" sz="900" u="none" strike="noStrike">
+                          <a:effectLst/>
+                        </a:rPr>
+                        <a:t>&lt;dbl&gt;</a:t>
+                      </a:r>
+                      <a:endParaRPr lang="en-US" sz="900" b="0" i="0" u="none" strike="noStrike">
+                        <a:solidFill>
+                          <a:srgbClr val="000000"/>
+                        </a:solidFill>
+                        <a:effectLst/>
+                        <a:latin typeface="Calibri" panose="020F0502020204030204" pitchFamily="34" charset="0"/>
+                      </a:endParaRPr>
+                    </a:p>
+                  </a:txBody>
+                  <a:tcPr marL="6565" marR="6565" marT="6565" marB="0" anchor="b"/>
+                </a:tc>
+                <a:tc>
+                  <a:txBody>
+                    <a:bodyPr/>
+                    <a:lstStyle/>
+                    <a:p>
+                      <a:pPr algn="l" fontAlgn="b"/>
+                      <a:r>
+                        <a:rPr lang="en-US" sz="900" u="none" strike="noStrike">
+                          <a:effectLst/>
+                        </a:rPr>
+                        <a:t>&lt;dbl&gt;</a:t>
+                      </a:r>
+                      <a:endParaRPr lang="en-US" sz="900" b="0" i="0" u="none" strike="noStrike">
+                        <a:solidFill>
+                          <a:srgbClr val="000000"/>
+                        </a:solidFill>
+                        <a:effectLst/>
+                        <a:latin typeface="Calibri" panose="020F0502020204030204" pitchFamily="34" charset="0"/>
+                      </a:endParaRPr>
+                    </a:p>
+                  </a:txBody>
+                  <a:tcPr marL="6565" marR="6565" marT="6565" marB="0" anchor="b"/>
+                </a:tc>
+                <a:tc>
+                  <a:txBody>
+                    <a:bodyPr/>
+                    <a:lstStyle/>
+                    <a:p>
+                      <a:pPr algn="l" fontAlgn="b"/>
+                      <a:r>
+                        <a:rPr lang="en-US" sz="900" u="none" strike="noStrike">
+                          <a:effectLst/>
+                        </a:rPr>
+                        <a:t>&lt;dbl&gt;</a:t>
+                      </a:r>
+                      <a:endParaRPr lang="en-US" sz="900" b="0" i="0" u="none" strike="noStrike">
+                        <a:solidFill>
+                          <a:srgbClr val="000000"/>
+                        </a:solidFill>
+                        <a:effectLst/>
+                        <a:latin typeface="Calibri" panose="020F0502020204030204" pitchFamily="34" charset="0"/>
+                      </a:endParaRPr>
+                    </a:p>
+                  </a:txBody>
+                  <a:tcPr marL="6565" marR="6565" marT="6565" marB="0" anchor="b"/>
+                </a:tc>
+                <a:tc>
+                  <a:txBody>
+                    <a:bodyPr/>
+                    <a:lstStyle/>
+                    <a:p>
+                      <a:pPr algn="l" fontAlgn="b"/>
+                      <a:r>
+                        <a:rPr lang="en-US" sz="900" u="none" strike="noStrike">
+                          <a:effectLst/>
+                        </a:rPr>
+                        <a:t>&lt;dbl&gt;</a:t>
+                      </a:r>
+                      <a:endParaRPr lang="en-US" sz="900" b="0" i="0" u="none" strike="noStrike">
+                        <a:solidFill>
+                          <a:srgbClr val="000000"/>
+                        </a:solidFill>
+                        <a:effectLst/>
+                        <a:latin typeface="Calibri" panose="020F0502020204030204" pitchFamily="34" charset="0"/>
+                      </a:endParaRPr>
+                    </a:p>
+                  </a:txBody>
+                  <a:tcPr marL="6565" marR="6565" marT="6565" marB="0" anchor="b"/>
+                </a:tc>
+                <a:tc>
+                  <a:txBody>
+                    <a:bodyPr/>
+                    <a:lstStyle/>
+                    <a:p>
+                      <a:pPr algn="l" fontAlgn="b"/>
+                      <a:r>
+                        <a:rPr lang="en-US" sz="900" u="none" strike="noStrike">
+                          <a:effectLst/>
+                        </a:rPr>
+                        <a:t>&lt;dbl&gt;</a:t>
+                      </a:r>
+                      <a:endParaRPr lang="en-US" sz="900" b="0" i="0" u="none" strike="noStrike">
+                        <a:solidFill>
+                          <a:srgbClr val="000000"/>
+                        </a:solidFill>
+                        <a:effectLst/>
+                        <a:latin typeface="Calibri" panose="020F0502020204030204" pitchFamily="34" charset="0"/>
+                      </a:endParaRPr>
+                    </a:p>
+                  </a:txBody>
+                  <a:tcPr marL="6565" marR="6565" marT="6565" marB="0" anchor="b"/>
+                </a:tc>
+                <a:tc>
+                  <a:txBody>
+                    <a:bodyPr/>
+                    <a:lstStyle/>
+                    <a:p>
+                      <a:pPr algn="l" fontAlgn="b"/>
+                      <a:r>
+                        <a:rPr lang="en-US" sz="900" u="none" strike="noStrike">
+                          <a:effectLst/>
+                        </a:rPr>
+                        <a:t>&lt;dbl&gt;</a:t>
+                      </a:r>
+                      <a:endParaRPr lang="en-US" sz="900" b="0" i="0" u="none" strike="noStrike">
+                        <a:solidFill>
+                          <a:srgbClr val="000000"/>
+                        </a:solidFill>
+                        <a:effectLst/>
+                        <a:latin typeface="Calibri" panose="020F0502020204030204" pitchFamily="34" charset="0"/>
+                      </a:endParaRPr>
+                    </a:p>
+                  </a:txBody>
+                  <a:tcPr marL="6565" marR="6565" marT="6565" marB="0" anchor="b"/>
+                </a:tc>
+                <a:tc>
+                  <a:txBody>
+                    <a:bodyPr/>
+                    <a:lstStyle/>
+                    <a:p>
+                      <a:pPr algn="l" fontAlgn="b"/>
+                      <a:r>
+                        <a:rPr lang="en-US" sz="900" u="none" strike="noStrike">
+                          <a:effectLst/>
+                        </a:rPr>
+                        <a:t>&lt;dbl&gt;</a:t>
+                      </a:r>
+                      <a:endParaRPr lang="en-US" sz="900" b="0" i="0" u="none" strike="noStrike">
+                        <a:solidFill>
+                          <a:srgbClr val="000000"/>
+                        </a:solidFill>
+                        <a:effectLst/>
+                        <a:latin typeface="Calibri" panose="020F0502020204030204" pitchFamily="34" charset="0"/>
+                      </a:endParaRPr>
+                    </a:p>
+                  </a:txBody>
+                  <a:tcPr marL="6565" marR="6565" marT="6565" marB="0" anchor="b"/>
+                </a:tc>
+                <a:tc>
+                  <a:txBody>
+                    <a:bodyPr/>
+                    <a:lstStyle/>
+                    <a:p>
+                      <a:pPr algn="l" fontAlgn="b"/>
+                      <a:r>
+                        <a:rPr lang="en-US" sz="900" u="none" strike="noStrike">
+                          <a:effectLst/>
+                        </a:rPr>
+                        <a:t>&lt;dbl&gt;</a:t>
+                      </a:r>
+                      <a:endParaRPr lang="en-US" sz="900" b="0" i="0" u="none" strike="noStrike">
+                        <a:solidFill>
+                          <a:srgbClr val="000000"/>
+                        </a:solidFill>
+                        <a:effectLst/>
+                        <a:latin typeface="Calibri" panose="020F0502020204030204" pitchFamily="34" charset="0"/>
+                      </a:endParaRPr>
+                    </a:p>
+                  </a:txBody>
+                  <a:tcPr marL="6565" marR="6565" marT="6565" marB="0" anchor="b"/>
+                </a:tc>
+                <a:extLst>
+                  <a:ext uri="{0D108BD9-81ED-4DB2-BD59-A6C34878D82A}">
+                    <a16:rowId xmlns:a16="http://schemas.microsoft.com/office/drawing/2014/main" val="1553581647"/>
+                  </a:ext>
+                </a:extLst>
+              </a:tr>
+              <a:tr h="157570">
+                <a:tc>
+                  <a:txBody>
+                    <a:bodyPr/>
+                    <a:lstStyle/>
+                    <a:p>
+                      <a:pPr algn="l" fontAlgn="b"/>
+                      <a:r>
+                        <a:rPr lang="en-US" sz="900" u="none" strike="noStrike">
+                          <a:effectLst/>
+                        </a:rPr>
+                        <a:t>X15_sablefishBiomass_predAK_smoltyr</a:t>
+                      </a:r>
+                      <a:endParaRPr lang="en-US" sz="900" b="0" i="0" u="none" strike="noStrike">
+                        <a:solidFill>
+                          <a:srgbClr val="000000"/>
+                        </a:solidFill>
+                        <a:effectLst/>
+                        <a:latin typeface="Calibri" panose="020F0502020204030204" pitchFamily="34" charset="0"/>
+                      </a:endParaRPr>
+                    </a:p>
+                  </a:txBody>
+                  <a:tcPr marL="6565" marR="6565" marT="6565" marB="0" anchor="b"/>
+                </a:tc>
+                <a:tc>
+                  <a:txBody>
+                    <a:bodyPr/>
+                    <a:lstStyle/>
+                    <a:p>
+                      <a:pPr algn="l" fontAlgn="b"/>
+                      <a:r>
+                        <a:rPr lang="en-US" sz="900" u="none" strike="noStrike">
+                          <a:effectLst/>
+                        </a:rPr>
+                        <a:t>X13_pollock_age1plus_smoltyr + X12_egoa_krill_smoltyr</a:t>
+                      </a:r>
+                      <a:endParaRPr lang="en-US" sz="900" b="0" i="0" u="none" strike="noStrike">
+                        <a:solidFill>
+                          <a:srgbClr val="000000"/>
+                        </a:solidFill>
+                        <a:effectLst/>
+                        <a:latin typeface="Calibri" panose="020F0502020204030204" pitchFamily="34" charset="0"/>
+                      </a:endParaRPr>
+                    </a:p>
+                  </a:txBody>
+                  <a:tcPr marL="6565" marR="6565" marT="6565" marB="0" anchor="b"/>
+                </a:tc>
+                <a:tc>
+                  <a:txBody>
+                    <a:bodyPr/>
+                    <a:lstStyle/>
+                    <a:p>
+                      <a:pPr algn="l" fontAlgn="b"/>
+                      <a:r>
+                        <a:rPr lang="en-US" sz="900" u="none" strike="noStrike">
+                          <a:effectLst/>
+                        </a:rPr>
+                        <a:t>1; 1</a:t>
+                      </a:r>
+                      <a:endParaRPr lang="en-US" sz="900" b="0" i="0" u="none" strike="noStrike">
+                        <a:solidFill>
+                          <a:srgbClr val="000000"/>
+                        </a:solidFill>
+                        <a:effectLst/>
+                        <a:latin typeface="Calibri" panose="020F0502020204030204" pitchFamily="34" charset="0"/>
+                      </a:endParaRPr>
+                    </a:p>
+                  </a:txBody>
+                  <a:tcPr marL="6565" marR="6565" marT="6565" marB="0" anchor="b"/>
+                </a:tc>
+                <a:tc>
+                  <a:txBody>
+                    <a:bodyPr/>
+                    <a:lstStyle/>
+                    <a:p>
+                      <a:pPr algn="r" fontAlgn="b"/>
+                      <a:r>
+                        <a:rPr lang="en-US" sz="900" u="none" strike="noStrike">
+                          <a:effectLst/>
+                        </a:rPr>
+                        <a:t>-2.87</a:t>
+                      </a:r>
+                      <a:endParaRPr lang="en-US" sz="900" b="0" i="0" u="none" strike="noStrike">
+                        <a:solidFill>
+                          <a:srgbClr val="000000"/>
+                        </a:solidFill>
+                        <a:effectLst/>
+                        <a:latin typeface="Calibri" panose="020F0502020204030204" pitchFamily="34" charset="0"/>
+                      </a:endParaRPr>
+                    </a:p>
+                  </a:txBody>
+                  <a:tcPr marL="6565" marR="6565" marT="6565" marB="0" anchor="b"/>
+                </a:tc>
+                <a:tc>
+                  <a:txBody>
+                    <a:bodyPr/>
+                    <a:lstStyle/>
+                    <a:p>
+                      <a:pPr algn="r" fontAlgn="b"/>
+                      <a:r>
+                        <a:rPr lang="en-US" sz="900" u="none" strike="noStrike">
+                          <a:effectLst/>
+                        </a:rPr>
+                        <a:t>0.00106</a:t>
+                      </a:r>
+                      <a:endParaRPr lang="en-US" sz="900" b="0" i="0" u="none" strike="noStrike">
+                        <a:solidFill>
+                          <a:srgbClr val="000000"/>
+                        </a:solidFill>
+                        <a:effectLst/>
+                        <a:latin typeface="Calibri" panose="020F0502020204030204" pitchFamily="34" charset="0"/>
+                      </a:endParaRPr>
+                    </a:p>
+                  </a:txBody>
+                  <a:tcPr marL="6565" marR="6565" marT="6565" marB="0" anchor="b"/>
+                </a:tc>
+                <a:tc>
+                  <a:txBody>
+                    <a:bodyPr/>
+                    <a:lstStyle/>
+                    <a:p>
+                      <a:pPr algn="r" fontAlgn="b"/>
+                      <a:r>
+                        <a:rPr lang="en-US" sz="900" u="none" strike="noStrike">
+                          <a:effectLst/>
+                        </a:rPr>
+                        <a:t>-0.465</a:t>
+                      </a:r>
+                      <a:endParaRPr lang="en-US" sz="900" b="0" i="0" u="none" strike="noStrike">
+                        <a:solidFill>
+                          <a:srgbClr val="000000"/>
+                        </a:solidFill>
+                        <a:effectLst/>
+                        <a:latin typeface="Calibri" panose="020F0502020204030204" pitchFamily="34" charset="0"/>
+                      </a:endParaRPr>
+                    </a:p>
+                  </a:txBody>
+                  <a:tcPr marL="6565" marR="6565" marT="6565" marB="0" anchor="b"/>
+                </a:tc>
+                <a:tc>
+                  <a:txBody>
+                    <a:bodyPr/>
+                    <a:lstStyle/>
+                    <a:p>
+                      <a:pPr algn="r" fontAlgn="b"/>
+                      <a:r>
+                        <a:rPr lang="en-US" sz="900" u="none" strike="noStrike">
+                          <a:effectLst/>
+                        </a:rPr>
+                        <a:t>-0.158</a:t>
+                      </a:r>
+                      <a:endParaRPr lang="en-US" sz="900" b="0" i="0" u="none" strike="noStrike">
+                        <a:solidFill>
+                          <a:srgbClr val="000000"/>
+                        </a:solidFill>
+                        <a:effectLst/>
+                        <a:latin typeface="Calibri" panose="020F0502020204030204" pitchFamily="34" charset="0"/>
+                      </a:endParaRPr>
+                    </a:p>
+                  </a:txBody>
+                  <a:tcPr marL="6565" marR="6565" marT="6565" marB="0" anchor="b"/>
+                </a:tc>
+                <a:tc>
+                  <a:txBody>
+                    <a:bodyPr/>
+                    <a:lstStyle/>
+                    <a:p>
+                      <a:pPr algn="r" fontAlgn="b"/>
+                      <a:r>
+                        <a:rPr lang="en-US" sz="900" u="none" strike="noStrike">
+                          <a:effectLst/>
+                        </a:rPr>
+                        <a:t>78.7</a:t>
+                      </a:r>
+                      <a:endParaRPr lang="en-US" sz="900" b="0" i="0" u="none" strike="noStrike">
+                        <a:solidFill>
+                          <a:srgbClr val="000000"/>
+                        </a:solidFill>
+                        <a:effectLst/>
+                        <a:latin typeface="Calibri" panose="020F0502020204030204" pitchFamily="34" charset="0"/>
+                      </a:endParaRPr>
+                    </a:p>
+                  </a:txBody>
+                  <a:tcPr marL="6565" marR="6565" marT="6565" marB="0" anchor="b"/>
+                </a:tc>
+                <a:tc>
+                  <a:txBody>
+                    <a:bodyPr/>
+                    <a:lstStyle/>
+                    <a:p>
+                      <a:pPr algn="r" fontAlgn="b"/>
+                      <a:r>
+                        <a:rPr lang="en-US" sz="900" u="none" strike="noStrike">
+                          <a:effectLst/>
+                        </a:rPr>
+                        <a:t>1.1</a:t>
+                      </a:r>
+                      <a:endParaRPr lang="en-US" sz="900" b="0" i="0" u="none" strike="noStrike">
+                        <a:solidFill>
+                          <a:srgbClr val="000000"/>
+                        </a:solidFill>
+                        <a:effectLst/>
+                        <a:latin typeface="Calibri" panose="020F0502020204030204" pitchFamily="34" charset="0"/>
+                      </a:endParaRPr>
+                    </a:p>
+                  </a:txBody>
+                  <a:tcPr marL="6565" marR="6565" marT="6565" marB="0" anchor="b"/>
+                </a:tc>
+                <a:tc>
+                  <a:txBody>
+                    <a:bodyPr/>
+                    <a:lstStyle/>
+                    <a:p>
+                      <a:pPr algn="r" fontAlgn="b"/>
+                      <a:r>
+                        <a:rPr lang="en-US" sz="900" u="none" strike="noStrike">
+                          <a:effectLst/>
+                        </a:rPr>
+                        <a:t>9.43</a:t>
+                      </a:r>
+                      <a:endParaRPr lang="en-US" sz="900" b="0" i="0" u="none" strike="noStrike">
+                        <a:solidFill>
+                          <a:srgbClr val="000000"/>
+                        </a:solidFill>
+                        <a:effectLst/>
+                        <a:latin typeface="Calibri" panose="020F0502020204030204" pitchFamily="34" charset="0"/>
+                      </a:endParaRPr>
+                    </a:p>
+                  </a:txBody>
+                  <a:tcPr marL="6565" marR="6565" marT="6565" marB="0" anchor="b"/>
+                </a:tc>
+                <a:tc>
+                  <a:txBody>
+                    <a:bodyPr/>
+                    <a:lstStyle/>
+                    <a:p>
+                      <a:pPr algn="r" fontAlgn="b"/>
+                      <a:r>
+                        <a:rPr lang="en-US" sz="900" u="none" strike="noStrike">
+                          <a:effectLst/>
+                        </a:rPr>
+                        <a:t>-8.33</a:t>
+                      </a:r>
+                      <a:endParaRPr lang="en-US" sz="900" b="0" i="0" u="none" strike="noStrike">
+                        <a:solidFill>
+                          <a:srgbClr val="000000"/>
+                        </a:solidFill>
+                        <a:effectLst/>
+                        <a:latin typeface="Calibri" panose="020F0502020204030204" pitchFamily="34" charset="0"/>
+                      </a:endParaRPr>
+                    </a:p>
+                  </a:txBody>
+                  <a:tcPr marL="6565" marR="6565" marT="6565" marB="0" anchor="b"/>
+                </a:tc>
+                <a:extLst>
+                  <a:ext uri="{0D108BD9-81ED-4DB2-BD59-A6C34878D82A}">
+                    <a16:rowId xmlns:a16="http://schemas.microsoft.com/office/drawing/2014/main" val="36191823"/>
+                  </a:ext>
+                </a:extLst>
+              </a:tr>
+              <a:tr h="157570">
+                <a:tc>
+                  <a:txBody>
+                    <a:bodyPr/>
+                    <a:lstStyle/>
+                    <a:p>
+                      <a:pPr algn="l" fontAlgn="b"/>
+                      <a:r>
+                        <a:rPr lang="en-US" sz="900" u="none" strike="noStrike">
+                          <a:effectLst/>
+                        </a:rPr>
+                        <a:t>X15_sablefishBiomass_predAK_adultyr</a:t>
+                      </a:r>
+                      <a:endParaRPr lang="en-US" sz="900" b="0" i="0" u="none" strike="noStrike">
+                        <a:solidFill>
+                          <a:srgbClr val="000000"/>
+                        </a:solidFill>
+                        <a:effectLst/>
+                        <a:latin typeface="Calibri" panose="020F0502020204030204" pitchFamily="34" charset="0"/>
+                      </a:endParaRPr>
+                    </a:p>
+                  </a:txBody>
+                  <a:tcPr marL="6565" marR="6565" marT="6565" marB="0" anchor="b"/>
+                </a:tc>
+                <a:tc>
+                  <a:txBody>
+                    <a:bodyPr/>
+                    <a:lstStyle/>
+                    <a:p>
+                      <a:pPr algn="l" fontAlgn="b"/>
+                      <a:r>
+                        <a:rPr lang="en-US" sz="900" u="none" strike="noStrike">
+                          <a:effectLst/>
+                        </a:rPr>
+                        <a:t>X13_pollock_age1plus_adultyr + X12_egoa_krill_smoltyr</a:t>
+                      </a:r>
+                      <a:endParaRPr lang="en-US" sz="900" b="0" i="0" u="none" strike="noStrike">
+                        <a:solidFill>
+                          <a:srgbClr val="000000"/>
+                        </a:solidFill>
+                        <a:effectLst/>
+                        <a:latin typeface="Calibri" panose="020F0502020204030204" pitchFamily="34" charset="0"/>
+                      </a:endParaRPr>
+                    </a:p>
+                  </a:txBody>
+                  <a:tcPr marL="6565" marR="6565" marT="6565" marB="0" anchor="b"/>
+                </a:tc>
+                <a:tc>
+                  <a:txBody>
+                    <a:bodyPr/>
+                    <a:lstStyle/>
+                    <a:p>
+                      <a:pPr algn="l" fontAlgn="b"/>
+                      <a:r>
+                        <a:rPr lang="en-US" sz="900" u="none" strike="noStrike">
+                          <a:effectLst/>
+                        </a:rPr>
+                        <a:t>1; 1</a:t>
+                      </a:r>
+                      <a:endParaRPr lang="en-US" sz="900" b="0" i="0" u="none" strike="noStrike">
+                        <a:solidFill>
+                          <a:srgbClr val="000000"/>
+                        </a:solidFill>
+                        <a:effectLst/>
+                        <a:latin typeface="Calibri" panose="020F0502020204030204" pitchFamily="34" charset="0"/>
+                      </a:endParaRPr>
+                    </a:p>
+                  </a:txBody>
+                  <a:tcPr marL="6565" marR="6565" marT="6565" marB="0" anchor="b"/>
+                </a:tc>
+                <a:tc>
+                  <a:txBody>
+                    <a:bodyPr/>
+                    <a:lstStyle/>
+                    <a:p>
+                      <a:pPr algn="r" fontAlgn="b"/>
+                      <a:r>
+                        <a:rPr lang="en-US" sz="900" u="none" strike="noStrike">
+                          <a:effectLst/>
+                        </a:rPr>
+                        <a:t>-2.52</a:t>
+                      </a:r>
+                      <a:endParaRPr lang="en-US" sz="900" b="0" i="0" u="none" strike="noStrike">
+                        <a:solidFill>
+                          <a:srgbClr val="000000"/>
+                        </a:solidFill>
+                        <a:effectLst/>
+                        <a:latin typeface="Calibri" panose="020F0502020204030204" pitchFamily="34" charset="0"/>
+                      </a:endParaRPr>
+                    </a:p>
+                  </a:txBody>
+                  <a:tcPr marL="6565" marR="6565" marT="6565" marB="0" anchor="b"/>
+                </a:tc>
+                <a:tc>
+                  <a:txBody>
+                    <a:bodyPr/>
+                    <a:lstStyle/>
+                    <a:p>
+                      <a:pPr algn="r" fontAlgn="b"/>
+                      <a:r>
+                        <a:rPr lang="en-US" sz="900" u="none" strike="noStrike">
+                          <a:effectLst/>
+                        </a:rPr>
+                        <a:t>0.00116</a:t>
+                      </a:r>
+                      <a:endParaRPr lang="en-US" sz="900" b="0" i="0" u="none" strike="noStrike">
+                        <a:solidFill>
+                          <a:srgbClr val="000000"/>
+                        </a:solidFill>
+                        <a:effectLst/>
+                        <a:latin typeface="Calibri" panose="020F0502020204030204" pitchFamily="34" charset="0"/>
+                      </a:endParaRPr>
+                    </a:p>
+                  </a:txBody>
+                  <a:tcPr marL="6565" marR="6565" marT="6565" marB="0" anchor="b"/>
+                </a:tc>
+                <a:tc>
+                  <a:txBody>
+                    <a:bodyPr/>
+                    <a:lstStyle/>
+                    <a:p>
+                      <a:pPr algn="r" fontAlgn="b"/>
+                      <a:r>
+                        <a:rPr lang="en-US" sz="900" u="none" strike="noStrike">
+                          <a:effectLst/>
+                        </a:rPr>
+                        <a:t>-0.463</a:t>
+                      </a:r>
+                      <a:endParaRPr lang="en-US" sz="900" b="0" i="0" u="none" strike="noStrike">
+                        <a:solidFill>
+                          <a:srgbClr val="000000"/>
+                        </a:solidFill>
+                        <a:effectLst/>
+                        <a:latin typeface="Calibri" panose="020F0502020204030204" pitchFamily="34" charset="0"/>
+                      </a:endParaRPr>
+                    </a:p>
+                  </a:txBody>
+                  <a:tcPr marL="6565" marR="6565" marT="6565" marB="0" anchor="b"/>
+                </a:tc>
+                <a:tc>
+                  <a:txBody>
+                    <a:bodyPr/>
+                    <a:lstStyle/>
+                    <a:p>
+                      <a:pPr algn="r" fontAlgn="b"/>
+                      <a:r>
+                        <a:rPr lang="en-US" sz="900" u="none" strike="noStrike">
+                          <a:effectLst/>
+                        </a:rPr>
+                        <a:t>-0.14</a:t>
+                      </a:r>
+                      <a:endParaRPr lang="en-US" sz="900" b="0" i="0" u="none" strike="noStrike">
+                        <a:solidFill>
+                          <a:srgbClr val="000000"/>
+                        </a:solidFill>
+                        <a:effectLst/>
+                        <a:latin typeface="Calibri" panose="020F0502020204030204" pitchFamily="34" charset="0"/>
+                      </a:endParaRPr>
+                    </a:p>
+                  </a:txBody>
+                  <a:tcPr marL="6565" marR="6565" marT="6565" marB="0" anchor="b"/>
+                </a:tc>
+                <a:tc>
+                  <a:txBody>
+                    <a:bodyPr/>
+                    <a:lstStyle/>
+                    <a:p>
+                      <a:pPr algn="r" fontAlgn="b"/>
+                      <a:r>
+                        <a:rPr lang="en-US" sz="900" u="none" strike="noStrike">
+                          <a:effectLst/>
+                        </a:rPr>
+                        <a:t>74.6</a:t>
+                      </a:r>
+                      <a:endParaRPr lang="en-US" sz="900" b="0" i="0" u="none" strike="noStrike">
+                        <a:solidFill>
+                          <a:srgbClr val="000000"/>
+                        </a:solidFill>
+                        <a:effectLst/>
+                        <a:latin typeface="Calibri" panose="020F0502020204030204" pitchFamily="34" charset="0"/>
+                      </a:endParaRPr>
+                    </a:p>
+                  </a:txBody>
+                  <a:tcPr marL="6565" marR="6565" marT="6565" marB="0" anchor="b"/>
+                </a:tc>
+                <a:tc>
+                  <a:txBody>
+                    <a:bodyPr/>
+                    <a:lstStyle/>
+                    <a:p>
+                      <a:pPr algn="r" fontAlgn="b"/>
+                      <a:r>
+                        <a:rPr lang="en-US" sz="900" u="none" strike="noStrike">
+                          <a:effectLst/>
+                        </a:rPr>
+                        <a:t>1.21</a:t>
+                      </a:r>
+                      <a:endParaRPr lang="en-US" sz="900" b="0" i="0" u="none" strike="noStrike">
+                        <a:solidFill>
+                          <a:srgbClr val="000000"/>
+                        </a:solidFill>
+                        <a:effectLst/>
+                        <a:latin typeface="Calibri" panose="020F0502020204030204" pitchFamily="34" charset="0"/>
+                      </a:endParaRPr>
+                    </a:p>
+                  </a:txBody>
+                  <a:tcPr marL="6565" marR="6565" marT="6565" marB="0" anchor="b"/>
+                </a:tc>
+                <a:tc>
+                  <a:txBody>
+                    <a:bodyPr/>
+                    <a:lstStyle/>
+                    <a:p>
+                      <a:pPr algn="r" fontAlgn="b"/>
+                      <a:r>
+                        <a:rPr lang="en-US" sz="900" u="none" strike="noStrike">
+                          <a:effectLst/>
+                        </a:rPr>
+                        <a:t>8.83</a:t>
+                      </a:r>
+                      <a:endParaRPr lang="en-US" sz="900" b="0" i="0" u="none" strike="noStrike">
+                        <a:solidFill>
+                          <a:srgbClr val="000000"/>
+                        </a:solidFill>
+                        <a:effectLst/>
+                        <a:latin typeface="Calibri" panose="020F0502020204030204" pitchFamily="34" charset="0"/>
+                      </a:endParaRPr>
+                    </a:p>
+                  </a:txBody>
+                  <a:tcPr marL="6565" marR="6565" marT="6565" marB="0" anchor="b"/>
+                </a:tc>
+                <a:tc>
+                  <a:txBody>
+                    <a:bodyPr/>
+                    <a:lstStyle/>
+                    <a:p>
+                      <a:pPr algn="r" fontAlgn="b"/>
+                      <a:r>
+                        <a:rPr lang="en-US" sz="900" u="none" strike="noStrike">
+                          <a:effectLst/>
+                        </a:rPr>
+                        <a:t>-7.63</a:t>
+                      </a:r>
+                      <a:endParaRPr lang="en-US" sz="900" b="0" i="0" u="none" strike="noStrike">
+                        <a:solidFill>
+                          <a:srgbClr val="000000"/>
+                        </a:solidFill>
+                        <a:effectLst/>
+                        <a:latin typeface="Calibri" panose="020F0502020204030204" pitchFamily="34" charset="0"/>
+                      </a:endParaRPr>
+                    </a:p>
+                  </a:txBody>
+                  <a:tcPr marL="6565" marR="6565" marT="6565" marB="0" anchor="b"/>
+                </a:tc>
+                <a:extLst>
+                  <a:ext uri="{0D108BD9-81ED-4DB2-BD59-A6C34878D82A}">
+                    <a16:rowId xmlns:a16="http://schemas.microsoft.com/office/drawing/2014/main" val="2868094857"/>
+                  </a:ext>
+                </a:extLst>
+              </a:tr>
+              <a:tr h="157570">
+                <a:tc>
+                  <a:txBody>
+                    <a:bodyPr/>
+                    <a:lstStyle/>
+                    <a:p>
+                      <a:pPr algn="l" fontAlgn="b"/>
+                      <a:r>
+                        <a:rPr lang="en-US" sz="900" u="none" strike="noStrike">
+                          <a:effectLst/>
+                        </a:rPr>
+                        <a:t>X10_Harbour_s_2yrLead_WS_adultyr</a:t>
+                      </a:r>
+                      <a:endParaRPr lang="en-US" sz="900" b="0" i="0" u="none" strike="noStrike">
+                        <a:solidFill>
+                          <a:srgbClr val="000000"/>
+                        </a:solidFill>
+                        <a:effectLst/>
+                        <a:latin typeface="Calibri" panose="020F0502020204030204" pitchFamily="34" charset="0"/>
+                      </a:endParaRPr>
+                    </a:p>
+                  </a:txBody>
+                  <a:tcPr marL="6565" marR="6565" marT="6565" marB="0" anchor="b"/>
+                </a:tc>
+                <a:tc>
+                  <a:txBody>
+                    <a:bodyPr/>
+                    <a:lstStyle/>
+                    <a:p>
+                      <a:pPr algn="l" fontAlgn="b"/>
+                      <a:r>
+                        <a:rPr lang="en-US" sz="900" u="none" strike="noStrike">
+                          <a:effectLst/>
+                        </a:rPr>
+                        <a:t>None (Unattenuated)</a:t>
+                      </a:r>
+                      <a:endParaRPr lang="en-US" sz="900" b="0" i="0" u="none" strike="noStrike">
+                        <a:solidFill>
+                          <a:srgbClr val="000000"/>
+                        </a:solidFill>
+                        <a:effectLst/>
+                        <a:latin typeface="Calibri" panose="020F0502020204030204" pitchFamily="34" charset="0"/>
+                      </a:endParaRPr>
+                    </a:p>
+                  </a:txBody>
+                  <a:tcPr marL="6565" marR="6565" marT="6565" marB="0" anchor="b"/>
+                </a:tc>
+                <a:tc>
+                  <a:txBody>
+                    <a:bodyPr/>
+                    <a:lstStyle/>
+                    <a:p>
+                      <a:pPr algn="l" fontAlgn="b"/>
+                      <a:r>
+                        <a:rPr lang="en-US" sz="900" u="none" strike="noStrike">
+                          <a:effectLst/>
+                        </a:rPr>
+                        <a:t>None</a:t>
+                      </a:r>
+                      <a:endParaRPr lang="en-US" sz="900" b="0" i="0" u="none" strike="noStrike">
+                        <a:solidFill>
+                          <a:srgbClr val="000000"/>
+                        </a:solidFill>
+                        <a:effectLst/>
+                        <a:latin typeface="Calibri" panose="020F0502020204030204" pitchFamily="34" charset="0"/>
+                      </a:endParaRPr>
+                    </a:p>
+                  </a:txBody>
+                  <a:tcPr marL="6565" marR="6565" marT="6565" marB="0" anchor="b"/>
+                </a:tc>
+                <a:tc>
+                  <a:txBody>
+                    <a:bodyPr/>
+                    <a:lstStyle/>
+                    <a:p>
+                      <a:pPr algn="r" fontAlgn="b"/>
+                      <a:r>
+                        <a:rPr lang="en-US" sz="900" u="none" strike="noStrike">
+                          <a:effectLst/>
+                        </a:rPr>
+                        <a:t>-0.546</a:t>
+                      </a:r>
+                      <a:endParaRPr lang="en-US" sz="900" b="0" i="0" u="none" strike="noStrike">
+                        <a:solidFill>
+                          <a:srgbClr val="000000"/>
+                        </a:solidFill>
+                        <a:effectLst/>
+                        <a:latin typeface="Calibri" panose="020F0502020204030204" pitchFamily="34" charset="0"/>
+                      </a:endParaRPr>
+                    </a:p>
+                  </a:txBody>
+                  <a:tcPr marL="6565" marR="6565" marT="6565" marB="0" anchor="b"/>
+                </a:tc>
+                <a:tc>
+                  <a:txBody>
+                    <a:bodyPr/>
+                    <a:lstStyle/>
+                    <a:p>
+                      <a:pPr algn="r" fontAlgn="b"/>
+                      <a:r>
+                        <a:rPr lang="en-US" sz="900" u="none" strike="noStrike">
+                          <a:effectLst/>
+                        </a:rPr>
+                        <a:t>0.00685</a:t>
+                      </a:r>
+                      <a:endParaRPr lang="en-US" sz="900" b="0" i="0" u="none" strike="noStrike">
+                        <a:solidFill>
+                          <a:srgbClr val="000000"/>
+                        </a:solidFill>
+                        <a:effectLst/>
+                        <a:latin typeface="Calibri" panose="020F0502020204030204" pitchFamily="34" charset="0"/>
+                      </a:endParaRPr>
+                    </a:p>
+                  </a:txBody>
+                  <a:tcPr marL="6565" marR="6565" marT="6565" marB="0" anchor="b"/>
+                </a:tc>
+                <a:tc>
+                  <a:txBody>
+                    <a:bodyPr/>
+                    <a:lstStyle/>
+                    <a:p>
+                      <a:pPr algn="r" fontAlgn="b"/>
+                      <a:r>
+                        <a:rPr lang="en-US" sz="900" u="none" strike="noStrike">
+                          <a:effectLst/>
+                        </a:rPr>
+                        <a:t>-0.41</a:t>
+                      </a:r>
+                      <a:endParaRPr lang="en-US" sz="900" b="0" i="0" u="none" strike="noStrike">
+                        <a:solidFill>
+                          <a:srgbClr val="000000"/>
+                        </a:solidFill>
+                        <a:effectLst/>
+                        <a:latin typeface="Calibri" panose="020F0502020204030204" pitchFamily="34" charset="0"/>
+                      </a:endParaRPr>
+                    </a:p>
+                  </a:txBody>
+                  <a:tcPr marL="6565" marR="6565" marT="6565" marB="0" anchor="b"/>
+                </a:tc>
+                <a:tc>
+                  <a:txBody>
+                    <a:bodyPr/>
+                    <a:lstStyle/>
+                    <a:p>
+                      <a:pPr algn="r" fontAlgn="b"/>
+                      <a:r>
+                        <a:rPr lang="en-US" sz="900" u="none" strike="noStrike">
+                          <a:effectLst/>
+                        </a:rPr>
+                        <a:t>-0.181</a:t>
+                      </a:r>
+                      <a:endParaRPr lang="en-US" sz="900" b="0" i="0" u="none" strike="noStrike">
+                        <a:solidFill>
+                          <a:srgbClr val="000000"/>
+                        </a:solidFill>
+                        <a:effectLst/>
+                        <a:latin typeface="Calibri" panose="020F0502020204030204" pitchFamily="34" charset="0"/>
+                      </a:endParaRPr>
+                    </a:p>
+                  </a:txBody>
+                  <a:tcPr marL="6565" marR="6565" marT="6565" marB="0" anchor="b"/>
+                </a:tc>
+                <a:tc>
+                  <a:txBody>
+                    <a:bodyPr/>
+                    <a:lstStyle/>
+                    <a:p>
+                      <a:pPr algn="r" fontAlgn="b"/>
+                      <a:r>
+                        <a:rPr lang="en-US" sz="900" u="none" strike="noStrike">
+                          <a:effectLst/>
+                        </a:rPr>
+                        <a:t>0</a:t>
+                      </a:r>
+                      <a:endParaRPr lang="en-US" sz="900" b="0" i="0" u="none" strike="noStrike">
+                        <a:solidFill>
+                          <a:srgbClr val="000000"/>
+                        </a:solidFill>
+                        <a:effectLst/>
+                        <a:latin typeface="Calibri" panose="020F0502020204030204" pitchFamily="34" charset="0"/>
+                      </a:endParaRPr>
+                    </a:p>
+                  </a:txBody>
+                  <a:tcPr marL="6565" marR="6565" marT="6565" marB="0" anchor="b"/>
+                </a:tc>
+                <a:tc>
+                  <a:txBody>
+                    <a:bodyPr/>
+                    <a:lstStyle/>
+                    <a:p>
+                      <a:pPr algn="r" fontAlgn="b"/>
+                      <a:r>
+                        <a:rPr lang="en-US" sz="900" u="none" strike="noStrike">
+                          <a:effectLst/>
+                        </a:rPr>
+                        <a:t>3.57</a:t>
+                      </a:r>
+                      <a:endParaRPr lang="en-US" sz="900" b="0" i="0" u="none" strike="noStrike">
+                        <a:solidFill>
+                          <a:srgbClr val="000000"/>
+                        </a:solidFill>
+                        <a:effectLst/>
+                        <a:latin typeface="Calibri" panose="020F0502020204030204" pitchFamily="34" charset="0"/>
+                      </a:endParaRPr>
+                    </a:p>
+                  </a:txBody>
+                  <a:tcPr marL="6565" marR="6565" marT="6565" marB="0" anchor="b"/>
+                </a:tc>
+                <a:tc>
+                  <a:txBody>
+                    <a:bodyPr/>
+                    <a:lstStyle/>
+                    <a:p>
+                      <a:pPr algn="r" fontAlgn="b"/>
+                      <a:r>
+                        <a:rPr lang="en-US" sz="900" u="none" strike="noStrike">
+                          <a:effectLst/>
+                        </a:rPr>
+                        <a:t>3.57</a:t>
+                      </a:r>
+                      <a:endParaRPr lang="en-US" sz="900" b="0" i="0" u="none" strike="noStrike">
+                        <a:solidFill>
+                          <a:srgbClr val="000000"/>
+                        </a:solidFill>
+                        <a:effectLst/>
+                        <a:latin typeface="Calibri" panose="020F0502020204030204" pitchFamily="34" charset="0"/>
+                      </a:endParaRPr>
+                    </a:p>
+                  </a:txBody>
+                  <a:tcPr marL="6565" marR="6565" marT="6565" marB="0" anchor="b"/>
+                </a:tc>
+                <a:tc>
+                  <a:txBody>
+                    <a:bodyPr/>
+                    <a:lstStyle/>
+                    <a:p>
+                      <a:pPr algn="r" fontAlgn="b"/>
+                      <a:r>
+                        <a:rPr lang="en-US" sz="900" u="none" strike="noStrike">
+                          <a:effectLst/>
+                        </a:rPr>
+                        <a:t>0</a:t>
+                      </a:r>
+                      <a:endParaRPr lang="en-US" sz="900" b="0" i="0" u="none" strike="noStrike">
+                        <a:solidFill>
+                          <a:srgbClr val="000000"/>
+                        </a:solidFill>
+                        <a:effectLst/>
+                        <a:latin typeface="Calibri" panose="020F0502020204030204" pitchFamily="34" charset="0"/>
+                      </a:endParaRPr>
+                    </a:p>
+                  </a:txBody>
+                  <a:tcPr marL="6565" marR="6565" marT="6565" marB="0" anchor="b"/>
+                </a:tc>
+                <a:extLst>
+                  <a:ext uri="{0D108BD9-81ED-4DB2-BD59-A6C34878D82A}">
+                    <a16:rowId xmlns:a16="http://schemas.microsoft.com/office/drawing/2014/main" val="2412215900"/>
+                  </a:ext>
+                </a:extLst>
+              </a:tr>
+              <a:tr h="157570">
+                <a:tc>
+                  <a:txBody>
+                    <a:bodyPr/>
+                    <a:lstStyle/>
+                    <a:p>
+                      <a:pPr algn="l" fontAlgn="b"/>
+                      <a:r>
+                        <a:rPr lang="en-US" sz="900" u="none" strike="noStrike">
+                          <a:effectLst/>
+                        </a:rPr>
+                        <a:t>X15_ArrowtoothFlounderBiomass_predAK_adultyr</a:t>
+                      </a:r>
+                      <a:endParaRPr lang="en-US" sz="900" b="0" i="0" u="none" strike="noStrike">
+                        <a:solidFill>
+                          <a:srgbClr val="000000"/>
+                        </a:solidFill>
+                        <a:effectLst/>
+                        <a:latin typeface="Calibri" panose="020F0502020204030204" pitchFamily="34" charset="0"/>
+                      </a:endParaRPr>
+                    </a:p>
+                  </a:txBody>
+                  <a:tcPr marL="6565" marR="6565" marT="6565" marB="0" anchor="b"/>
+                </a:tc>
+                <a:tc>
+                  <a:txBody>
+                    <a:bodyPr/>
+                    <a:lstStyle/>
+                    <a:p>
+                      <a:pPr algn="l" fontAlgn="b"/>
+                      <a:r>
+                        <a:rPr lang="it-IT" sz="900" u="none" strike="noStrike">
+                          <a:effectLst/>
+                        </a:rPr>
+                        <a:t>X13_mid_il_capelin_smoltyr</a:t>
+                      </a:r>
+                      <a:endParaRPr lang="it-IT" sz="900" b="0" i="0" u="none" strike="noStrike">
+                        <a:solidFill>
+                          <a:srgbClr val="000000"/>
+                        </a:solidFill>
+                        <a:effectLst/>
+                        <a:latin typeface="Calibri" panose="020F0502020204030204" pitchFamily="34" charset="0"/>
+                      </a:endParaRPr>
+                    </a:p>
+                  </a:txBody>
+                  <a:tcPr marL="6565" marR="6565" marT="6565" marB="0" anchor="b"/>
+                </a:tc>
+                <a:tc>
+                  <a:txBody>
+                    <a:bodyPr/>
+                    <a:lstStyle/>
+                    <a:p>
+                      <a:pPr algn="r" fontAlgn="b"/>
+                      <a:r>
+                        <a:rPr lang="en-US" sz="900" u="none" strike="noStrike">
+                          <a:effectLst/>
+                        </a:rPr>
+                        <a:t>1</a:t>
+                      </a:r>
+                      <a:endParaRPr lang="en-US" sz="900" b="0" i="0" u="none" strike="noStrike">
+                        <a:solidFill>
+                          <a:srgbClr val="000000"/>
+                        </a:solidFill>
+                        <a:effectLst/>
+                        <a:latin typeface="Calibri" panose="020F0502020204030204" pitchFamily="34" charset="0"/>
+                      </a:endParaRPr>
+                    </a:p>
+                  </a:txBody>
+                  <a:tcPr marL="6565" marR="6565" marT="6565" marB="0" anchor="b"/>
+                </a:tc>
+                <a:tc>
+                  <a:txBody>
+                    <a:bodyPr/>
+                    <a:lstStyle/>
+                    <a:p>
+                      <a:pPr algn="r" fontAlgn="b"/>
+                      <a:r>
+                        <a:rPr lang="en-US" sz="900" u="none" strike="noStrike">
+                          <a:effectLst/>
+                        </a:rPr>
+                        <a:t>-0.32</a:t>
+                      </a:r>
+                      <a:endParaRPr lang="en-US" sz="900" b="0" i="0" u="none" strike="noStrike">
+                        <a:solidFill>
+                          <a:srgbClr val="000000"/>
+                        </a:solidFill>
+                        <a:effectLst/>
+                        <a:latin typeface="Calibri" panose="020F0502020204030204" pitchFamily="34" charset="0"/>
+                      </a:endParaRPr>
+                    </a:p>
+                  </a:txBody>
+                  <a:tcPr marL="6565" marR="6565" marT="6565" marB="0" anchor="b"/>
+                </a:tc>
+                <a:tc>
+                  <a:txBody>
+                    <a:bodyPr/>
+                    <a:lstStyle/>
+                    <a:p>
+                      <a:pPr algn="r" fontAlgn="b"/>
+                      <a:r>
+                        <a:rPr lang="en-US" sz="900" u="none" strike="noStrike">
+                          <a:effectLst/>
+                        </a:rPr>
+                        <a:t>0.0134</a:t>
+                      </a:r>
+                      <a:endParaRPr lang="en-US" sz="900" b="0" i="0" u="none" strike="noStrike">
+                        <a:solidFill>
+                          <a:srgbClr val="000000"/>
+                        </a:solidFill>
+                        <a:effectLst/>
+                        <a:latin typeface="Calibri" panose="020F0502020204030204" pitchFamily="34" charset="0"/>
+                      </a:endParaRPr>
+                    </a:p>
+                  </a:txBody>
+                  <a:tcPr marL="6565" marR="6565" marT="6565" marB="0" anchor="b"/>
+                </a:tc>
+                <a:tc>
+                  <a:txBody>
+                    <a:bodyPr/>
+                    <a:lstStyle/>
+                    <a:p>
+                      <a:pPr algn="r" fontAlgn="b"/>
+                      <a:r>
+                        <a:rPr lang="en-US" sz="900" u="none" strike="noStrike">
+                          <a:effectLst/>
+                        </a:rPr>
+                        <a:t>-0.378</a:t>
+                      </a:r>
+                      <a:endParaRPr lang="en-US" sz="900" b="0" i="0" u="none" strike="noStrike">
+                        <a:solidFill>
+                          <a:srgbClr val="000000"/>
+                        </a:solidFill>
+                        <a:effectLst/>
+                        <a:latin typeface="Calibri" panose="020F0502020204030204" pitchFamily="34" charset="0"/>
+                      </a:endParaRPr>
+                    </a:p>
+                  </a:txBody>
+                  <a:tcPr marL="6565" marR="6565" marT="6565" marB="0" anchor="b"/>
+                </a:tc>
+                <a:tc>
+                  <a:txBody>
+                    <a:bodyPr/>
+                    <a:lstStyle/>
+                    <a:p>
+                      <a:pPr algn="r" fontAlgn="b"/>
+                      <a:r>
+                        <a:rPr lang="en-US" sz="900" u="none" strike="noStrike">
+                          <a:effectLst/>
+                        </a:rPr>
+                        <a:t>-0.136</a:t>
+                      </a:r>
+                      <a:endParaRPr lang="en-US" sz="900" b="0" i="0" u="none" strike="noStrike">
+                        <a:solidFill>
+                          <a:srgbClr val="000000"/>
+                        </a:solidFill>
+                        <a:effectLst/>
+                        <a:latin typeface="Calibri" panose="020F0502020204030204" pitchFamily="34" charset="0"/>
+                      </a:endParaRPr>
+                    </a:p>
+                  </a:txBody>
+                  <a:tcPr marL="6565" marR="6565" marT="6565" marB="0" anchor="b"/>
+                </a:tc>
+                <a:tc>
+                  <a:txBody>
+                    <a:bodyPr/>
+                    <a:lstStyle/>
+                    <a:p>
+                      <a:pPr algn="r" fontAlgn="b"/>
+                      <a:r>
+                        <a:rPr lang="en-US" sz="900" u="none" strike="noStrike">
+                          <a:effectLst/>
+                        </a:rPr>
+                        <a:t>27.7</a:t>
+                      </a:r>
+                      <a:endParaRPr lang="en-US" sz="900" b="0" i="0" u="none" strike="noStrike">
+                        <a:solidFill>
+                          <a:srgbClr val="000000"/>
+                        </a:solidFill>
+                        <a:effectLst/>
+                        <a:latin typeface="Calibri" panose="020F0502020204030204" pitchFamily="34" charset="0"/>
+                      </a:endParaRPr>
+                    </a:p>
+                  </a:txBody>
+                  <a:tcPr marL="6565" marR="6565" marT="6565" marB="0" anchor="b"/>
+                </a:tc>
+                <a:tc>
+                  <a:txBody>
+                    <a:bodyPr/>
+                    <a:lstStyle/>
+                    <a:p>
+                      <a:pPr algn="r" fontAlgn="b"/>
+                      <a:r>
+                        <a:rPr lang="en-US" sz="900" u="none" strike="noStrike">
+                          <a:effectLst/>
+                        </a:rPr>
+                        <a:t>4.51</a:t>
+                      </a:r>
+                      <a:endParaRPr lang="en-US" sz="900" b="0" i="0" u="none" strike="noStrike">
+                        <a:solidFill>
+                          <a:srgbClr val="000000"/>
+                        </a:solidFill>
+                        <a:effectLst/>
+                        <a:latin typeface="Calibri" panose="020F0502020204030204" pitchFamily="34" charset="0"/>
+                      </a:endParaRPr>
+                    </a:p>
+                  </a:txBody>
+                  <a:tcPr marL="6565" marR="6565" marT="6565" marB="0" anchor="b"/>
+                </a:tc>
+                <a:tc>
+                  <a:txBody>
+                    <a:bodyPr/>
+                    <a:lstStyle/>
+                    <a:p>
+                      <a:pPr algn="r" fontAlgn="b"/>
+                      <a:r>
+                        <a:rPr lang="en-US" sz="900" u="none" strike="noStrike">
+                          <a:effectLst/>
+                        </a:rPr>
+                        <a:t>8.43</a:t>
+                      </a:r>
+                      <a:endParaRPr lang="en-US" sz="900" b="0" i="0" u="none" strike="noStrike">
+                        <a:solidFill>
+                          <a:srgbClr val="000000"/>
+                        </a:solidFill>
+                        <a:effectLst/>
+                        <a:latin typeface="Calibri" panose="020F0502020204030204" pitchFamily="34" charset="0"/>
+                      </a:endParaRPr>
+                    </a:p>
+                  </a:txBody>
+                  <a:tcPr marL="6565" marR="6565" marT="6565" marB="0" anchor="b"/>
+                </a:tc>
+                <a:tc>
+                  <a:txBody>
+                    <a:bodyPr/>
+                    <a:lstStyle/>
+                    <a:p>
+                      <a:pPr algn="r" fontAlgn="b"/>
+                      <a:r>
+                        <a:rPr lang="en-US" sz="900" u="none" strike="noStrike">
+                          <a:effectLst/>
+                        </a:rPr>
+                        <a:t>-3.92</a:t>
+                      </a:r>
+                      <a:endParaRPr lang="en-US" sz="900" b="0" i="0" u="none" strike="noStrike">
+                        <a:solidFill>
+                          <a:srgbClr val="000000"/>
+                        </a:solidFill>
+                        <a:effectLst/>
+                        <a:latin typeface="Calibri" panose="020F0502020204030204" pitchFamily="34" charset="0"/>
+                      </a:endParaRPr>
+                    </a:p>
+                  </a:txBody>
+                  <a:tcPr marL="6565" marR="6565" marT="6565" marB="0" anchor="b"/>
+                </a:tc>
+                <a:extLst>
+                  <a:ext uri="{0D108BD9-81ED-4DB2-BD59-A6C34878D82A}">
+                    <a16:rowId xmlns:a16="http://schemas.microsoft.com/office/drawing/2014/main" val="2505749778"/>
+                  </a:ext>
+                </a:extLst>
+              </a:tr>
+              <a:tr h="157570">
+                <a:tc>
+                  <a:txBody>
+                    <a:bodyPr/>
+                    <a:lstStyle/>
+                    <a:p>
+                      <a:pPr algn="l" fontAlgn="b"/>
+                      <a:r>
+                        <a:rPr lang="en-US" sz="900" u="none" strike="noStrike">
+                          <a:effectLst/>
+                        </a:rPr>
+                        <a:t>X15_ArrowtoothFlounderBiomass_predAK_smoltyr</a:t>
+                      </a:r>
+                      <a:endParaRPr lang="en-US" sz="900" b="0" i="0" u="none" strike="noStrike">
+                        <a:solidFill>
+                          <a:srgbClr val="000000"/>
+                        </a:solidFill>
+                        <a:effectLst/>
+                        <a:latin typeface="Calibri" panose="020F0502020204030204" pitchFamily="34" charset="0"/>
+                      </a:endParaRPr>
+                    </a:p>
+                  </a:txBody>
+                  <a:tcPr marL="6565" marR="6565" marT="6565" marB="0" anchor="b"/>
+                </a:tc>
+                <a:tc>
+                  <a:txBody>
+                    <a:bodyPr/>
+                    <a:lstStyle/>
+                    <a:p>
+                      <a:pPr algn="l" fontAlgn="b"/>
+                      <a:r>
+                        <a:rPr lang="it-IT" sz="900" u="none" strike="noStrike">
+                          <a:effectLst/>
+                        </a:rPr>
+                        <a:t>X13_mid_il_capelin_smoltyr</a:t>
+                      </a:r>
+                      <a:endParaRPr lang="it-IT" sz="900" b="0" i="0" u="none" strike="noStrike">
+                        <a:solidFill>
+                          <a:srgbClr val="000000"/>
+                        </a:solidFill>
+                        <a:effectLst/>
+                        <a:latin typeface="Calibri" panose="020F0502020204030204" pitchFamily="34" charset="0"/>
+                      </a:endParaRPr>
+                    </a:p>
+                  </a:txBody>
+                  <a:tcPr marL="6565" marR="6565" marT="6565" marB="0" anchor="b"/>
+                </a:tc>
+                <a:tc>
+                  <a:txBody>
+                    <a:bodyPr/>
+                    <a:lstStyle/>
+                    <a:p>
+                      <a:pPr algn="r" fontAlgn="b"/>
+                      <a:r>
+                        <a:rPr lang="en-US" sz="900" u="none" strike="noStrike">
+                          <a:effectLst/>
+                        </a:rPr>
+                        <a:t>1</a:t>
+                      </a:r>
+                      <a:endParaRPr lang="en-US" sz="900" b="0" i="0" u="none" strike="noStrike">
+                        <a:solidFill>
+                          <a:srgbClr val="000000"/>
+                        </a:solidFill>
+                        <a:effectLst/>
+                        <a:latin typeface="Calibri" panose="020F0502020204030204" pitchFamily="34" charset="0"/>
+                      </a:endParaRPr>
+                    </a:p>
+                  </a:txBody>
+                  <a:tcPr marL="6565" marR="6565" marT="6565" marB="0" anchor="b"/>
+                </a:tc>
+                <a:tc>
+                  <a:txBody>
+                    <a:bodyPr/>
+                    <a:lstStyle/>
+                    <a:p>
+                      <a:pPr algn="r" fontAlgn="b"/>
+                      <a:r>
+                        <a:rPr lang="en-US" sz="900" u="none" strike="noStrike">
+                          <a:effectLst/>
+                        </a:rPr>
+                        <a:t>-0.27</a:t>
+                      </a:r>
+                      <a:endParaRPr lang="en-US" sz="900" b="0" i="0" u="none" strike="noStrike">
+                        <a:solidFill>
+                          <a:srgbClr val="000000"/>
+                        </a:solidFill>
+                        <a:effectLst/>
+                        <a:latin typeface="Calibri" panose="020F0502020204030204" pitchFamily="34" charset="0"/>
+                      </a:endParaRPr>
+                    </a:p>
+                  </a:txBody>
+                  <a:tcPr marL="6565" marR="6565" marT="6565" marB="0" anchor="b"/>
+                </a:tc>
+                <a:tc>
+                  <a:txBody>
+                    <a:bodyPr/>
+                    <a:lstStyle/>
+                    <a:p>
+                      <a:pPr algn="r" fontAlgn="b"/>
+                      <a:r>
+                        <a:rPr lang="en-US" sz="900" u="none" strike="noStrike">
+                          <a:effectLst/>
+                        </a:rPr>
+                        <a:t>0.0246</a:t>
+                      </a:r>
+                      <a:endParaRPr lang="en-US" sz="900" b="0" i="0" u="none" strike="noStrike">
+                        <a:solidFill>
+                          <a:srgbClr val="000000"/>
+                        </a:solidFill>
+                        <a:effectLst/>
+                        <a:latin typeface="Calibri" panose="020F0502020204030204" pitchFamily="34" charset="0"/>
+                      </a:endParaRPr>
+                    </a:p>
+                  </a:txBody>
+                  <a:tcPr marL="6565" marR="6565" marT="6565" marB="0" anchor="b"/>
+                </a:tc>
+                <a:tc>
+                  <a:txBody>
+                    <a:bodyPr/>
+                    <a:lstStyle/>
+                    <a:p>
+                      <a:pPr algn="r" fontAlgn="b"/>
+                      <a:r>
+                        <a:rPr lang="en-US" sz="900" u="none" strike="noStrike">
+                          <a:effectLst/>
+                        </a:rPr>
+                        <a:t>-0.349</a:t>
+                      </a:r>
+                      <a:endParaRPr lang="en-US" sz="900" b="0" i="0" u="none" strike="noStrike">
+                        <a:solidFill>
+                          <a:srgbClr val="000000"/>
+                        </a:solidFill>
+                        <a:effectLst/>
+                        <a:latin typeface="Calibri" panose="020F0502020204030204" pitchFamily="34" charset="0"/>
+                      </a:endParaRPr>
+                    </a:p>
+                  </a:txBody>
+                  <a:tcPr marL="6565" marR="6565" marT="6565" marB="0" anchor="b"/>
+                </a:tc>
+                <a:tc>
+                  <a:txBody>
+                    <a:bodyPr/>
+                    <a:lstStyle/>
+                    <a:p>
+                      <a:pPr algn="r" fontAlgn="b"/>
+                      <a:r>
+                        <a:rPr lang="en-US" sz="900" u="none" strike="noStrike">
+                          <a:effectLst/>
+                        </a:rPr>
+                        <a:t>-0.109</a:t>
+                      </a:r>
+                      <a:endParaRPr lang="en-US" sz="900" b="0" i="0" u="none" strike="noStrike">
+                        <a:solidFill>
+                          <a:srgbClr val="000000"/>
+                        </a:solidFill>
+                        <a:effectLst/>
+                        <a:latin typeface="Calibri" panose="020F0502020204030204" pitchFamily="34" charset="0"/>
+                      </a:endParaRPr>
+                    </a:p>
+                  </a:txBody>
+                  <a:tcPr marL="6565" marR="6565" marT="6565" marB="0" anchor="b"/>
+                </a:tc>
+                <a:tc>
+                  <a:txBody>
+                    <a:bodyPr/>
+                    <a:lstStyle/>
+                    <a:p>
+                      <a:pPr algn="r" fontAlgn="b"/>
+                      <a:r>
+                        <a:rPr lang="en-US" sz="900" u="none" strike="noStrike">
+                          <a:effectLst/>
+                        </a:rPr>
+                        <a:t>23.7</a:t>
+                      </a:r>
+                      <a:endParaRPr lang="en-US" sz="900" b="0" i="0" u="none" strike="noStrike">
+                        <a:solidFill>
+                          <a:srgbClr val="000000"/>
+                        </a:solidFill>
+                        <a:effectLst/>
+                        <a:latin typeface="Calibri" panose="020F0502020204030204" pitchFamily="34" charset="0"/>
+                      </a:endParaRPr>
+                    </a:p>
+                  </a:txBody>
+                  <a:tcPr marL="6565" marR="6565" marT="6565" marB="0" anchor="b"/>
+                </a:tc>
+                <a:tc>
+                  <a:txBody>
+                    <a:bodyPr/>
+                    <a:lstStyle/>
+                    <a:p>
+                      <a:pPr algn="r" fontAlgn="b"/>
+                      <a:r>
+                        <a:rPr lang="en-US" sz="900" u="none" strike="noStrike">
+                          <a:effectLst/>
+                        </a:rPr>
+                        <a:t>5.37</a:t>
+                      </a:r>
+                      <a:endParaRPr lang="en-US" sz="900" b="0" i="0" u="none" strike="noStrike">
+                        <a:solidFill>
+                          <a:srgbClr val="000000"/>
+                        </a:solidFill>
+                        <a:effectLst/>
+                        <a:latin typeface="Calibri" panose="020F0502020204030204" pitchFamily="34" charset="0"/>
+                      </a:endParaRPr>
+                    </a:p>
+                  </a:txBody>
+                  <a:tcPr marL="6565" marR="6565" marT="6565" marB="0" anchor="b"/>
+                </a:tc>
+                <a:tc>
+                  <a:txBody>
+                    <a:bodyPr/>
+                    <a:lstStyle/>
+                    <a:p>
+                      <a:pPr algn="r" fontAlgn="b"/>
+                      <a:r>
+                        <a:rPr lang="en-US" sz="900" u="none" strike="noStrike">
+                          <a:effectLst/>
+                        </a:rPr>
+                        <a:t>7.74</a:t>
+                      </a:r>
+                      <a:endParaRPr lang="en-US" sz="900" b="0" i="0" u="none" strike="noStrike">
+                        <a:solidFill>
+                          <a:srgbClr val="000000"/>
+                        </a:solidFill>
+                        <a:effectLst/>
+                        <a:latin typeface="Calibri" panose="020F0502020204030204" pitchFamily="34" charset="0"/>
+                      </a:endParaRPr>
+                    </a:p>
+                  </a:txBody>
+                  <a:tcPr marL="6565" marR="6565" marT="6565" marB="0" anchor="b"/>
+                </a:tc>
+                <a:tc>
+                  <a:txBody>
+                    <a:bodyPr/>
+                    <a:lstStyle/>
+                    <a:p>
+                      <a:pPr algn="r" fontAlgn="b"/>
+                      <a:r>
+                        <a:rPr lang="en-US" sz="900" u="none" strike="noStrike">
+                          <a:effectLst/>
+                        </a:rPr>
+                        <a:t>-2.37</a:t>
+                      </a:r>
+                      <a:endParaRPr lang="en-US" sz="900" b="0" i="0" u="none" strike="noStrike">
+                        <a:solidFill>
+                          <a:srgbClr val="000000"/>
+                        </a:solidFill>
+                        <a:effectLst/>
+                        <a:latin typeface="Calibri" panose="020F0502020204030204" pitchFamily="34" charset="0"/>
+                      </a:endParaRPr>
+                    </a:p>
+                  </a:txBody>
+                  <a:tcPr marL="6565" marR="6565" marT="6565" marB="0" anchor="b"/>
+                </a:tc>
+                <a:extLst>
+                  <a:ext uri="{0D108BD9-81ED-4DB2-BD59-A6C34878D82A}">
+                    <a16:rowId xmlns:a16="http://schemas.microsoft.com/office/drawing/2014/main" val="3928337479"/>
+                  </a:ext>
+                </a:extLst>
+              </a:tr>
+              <a:tr h="157570">
+                <a:tc>
+                  <a:txBody>
+                    <a:bodyPr/>
+                    <a:lstStyle/>
+                    <a:p>
+                      <a:pPr algn="l" fontAlgn="b"/>
+                      <a:r>
+                        <a:rPr lang="en-US" sz="900" u="none" strike="noStrike">
+                          <a:effectLst/>
+                        </a:rPr>
+                        <a:t>X11_ssl_seak_pup_pred</a:t>
+                      </a:r>
+                      <a:endParaRPr lang="en-US" sz="900" b="0" i="0" u="none" strike="noStrike">
+                        <a:solidFill>
+                          <a:srgbClr val="000000"/>
+                        </a:solidFill>
+                        <a:effectLst/>
+                        <a:latin typeface="Calibri" panose="020F0502020204030204" pitchFamily="34" charset="0"/>
+                      </a:endParaRPr>
+                    </a:p>
+                  </a:txBody>
+                  <a:tcPr marL="6565" marR="6565" marT="6565" marB="0" anchor="b"/>
+                </a:tc>
+                <a:tc>
+                  <a:txBody>
+                    <a:bodyPr/>
+                    <a:lstStyle/>
+                    <a:p>
+                      <a:pPr algn="l" fontAlgn="b"/>
+                      <a:r>
+                        <a:rPr lang="en-US" sz="900" u="none" strike="noStrike">
+                          <a:effectLst/>
+                        </a:rPr>
+                        <a:t>X13_sitkaHerring_EGoA_smoltyr + X13_mid_il_capelin_smoltyr</a:t>
+                      </a:r>
+                      <a:endParaRPr lang="en-US" sz="900" b="0" i="0" u="none" strike="noStrike">
+                        <a:solidFill>
+                          <a:srgbClr val="000000"/>
+                        </a:solidFill>
+                        <a:effectLst/>
+                        <a:latin typeface="Calibri" panose="020F0502020204030204" pitchFamily="34" charset="0"/>
+                      </a:endParaRPr>
+                    </a:p>
+                  </a:txBody>
+                  <a:tcPr marL="6565" marR="6565" marT="6565" marB="0" anchor="b"/>
+                </a:tc>
+                <a:tc>
+                  <a:txBody>
+                    <a:bodyPr/>
+                    <a:lstStyle/>
+                    <a:p>
+                      <a:pPr algn="l" fontAlgn="b"/>
+                      <a:r>
+                        <a:rPr lang="en-US" sz="900" u="none" strike="noStrike">
+                          <a:effectLst/>
+                        </a:rPr>
+                        <a:t>1; 1</a:t>
+                      </a:r>
+                      <a:endParaRPr lang="en-US" sz="900" b="0" i="0" u="none" strike="noStrike">
+                        <a:solidFill>
+                          <a:srgbClr val="000000"/>
+                        </a:solidFill>
+                        <a:effectLst/>
+                        <a:latin typeface="Calibri" panose="020F0502020204030204" pitchFamily="34" charset="0"/>
+                      </a:endParaRPr>
+                    </a:p>
+                  </a:txBody>
+                  <a:tcPr marL="6565" marR="6565" marT="6565" marB="0" anchor="b"/>
+                </a:tc>
+                <a:tc>
+                  <a:txBody>
+                    <a:bodyPr/>
+                    <a:lstStyle/>
+                    <a:p>
+                      <a:pPr algn="r" fontAlgn="b"/>
+                      <a:r>
+                        <a:rPr lang="en-US" sz="900" u="none" strike="noStrike">
+                          <a:effectLst/>
+                        </a:rPr>
+                        <a:t>-0.366</a:t>
+                      </a:r>
+                      <a:endParaRPr lang="en-US" sz="900" b="0" i="0" u="none" strike="noStrike">
+                        <a:solidFill>
+                          <a:srgbClr val="000000"/>
+                        </a:solidFill>
+                        <a:effectLst/>
+                        <a:latin typeface="Calibri" panose="020F0502020204030204" pitchFamily="34" charset="0"/>
+                      </a:endParaRPr>
+                    </a:p>
+                  </a:txBody>
+                  <a:tcPr marL="6565" marR="6565" marT="6565" marB="0" anchor="b"/>
+                </a:tc>
+                <a:tc>
+                  <a:txBody>
+                    <a:bodyPr/>
+                    <a:lstStyle/>
+                    <a:p>
+                      <a:pPr algn="r" fontAlgn="b"/>
+                      <a:r>
+                        <a:rPr lang="en-US" sz="900" u="none" strike="noStrike">
+                          <a:effectLst/>
+                        </a:rPr>
+                        <a:t>0.025</a:t>
+                      </a:r>
+                      <a:endParaRPr lang="en-US" sz="900" b="0" i="0" u="none" strike="noStrike">
+                        <a:solidFill>
+                          <a:srgbClr val="000000"/>
+                        </a:solidFill>
+                        <a:effectLst/>
+                        <a:latin typeface="Calibri" panose="020F0502020204030204" pitchFamily="34" charset="0"/>
+                      </a:endParaRPr>
+                    </a:p>
+                  </a:txBody>
+                  <a:tcPr marL="6565" marR="6565" marT="6565" marB="0" anchor="b"/>
+                </a:tc>
+                <a:tc>
+                  <a:txBody>
+                    <a:bodyPr/>
+                    <a:lstStyle/>
+                    <a:p>
+                      <a:pPr algn="r" fontAlgn="b"/>
+                      <a:r>
+                        <a:rPr lang="en-US" sz="900" u="none" strike="noStrike">
+                          <a:effectLst/>
+                        </a:rPr>
+                        <a:t>-0.378</a:t>
+                      </a:r>
+                      <a:endParaRPr lang="en-US" sz="900" b="0" i="0" u="none" strike="noStrike">
+                        <a:solidFill>
+                          <a:srgbClr val="000000"/>
+                        </a:solidFill>
+                        <a:effectLst/>
+                        <a:latin typeface="Calibri" panose="020F0502020204030204" pitchFamily="34" charset="0"/>
+                      </a:endParaRPr>
+                    </a:p>
+                  </a:txBody>
+                  <a:tcPr marL="6565" marR="6565" marT="6565" marB="0" anchor="b"/>
+                </a:tc>
+                <a:tc>
+                  <a:txBody>
+                    <a:bodyPr/>
+                    <a:lstStyle/>
+                    <a:p>
+                      <a:pPr algn="r" fontAlgn="b"/>
+                      <a:r>
+                        <a:rPr lang="en-US" sz="900" u="none" strike="noStrike">
+                          <a:effectLst/>
+                        </a:rPr>
+                        <a:t>-0.122</a:t>
+                      </a:r>
+                      <a:endParaRPr lang="en-US" sz="900" b="0" i="0" u="none" strike="noStrike">
+                        <a:solidFill>
+                          <a:srgbClr val="000000"/>
+                        </a:solidFill>
+                        <a:effectLst/>
+                        <a:latin typeface="Calibri" panose="020F0502020204030204" pitchFamily="34" charset="0"/>
+                      </a:endParaRPr>
+                    </a:p>
+                  </a:txBody>
+                  <a:tcPr marL="6565" marR="6565" marT="6565" marB="0" anchor="b"/>
+                </a:tc>
+                <a:tc>
+                  <a:txBody>
+                    <a:bodyPr/>
+                    <a:lstStyle/>
+                    <a:p>
+                      <a:pPr algn="r" fontAlgn="b"/>
+                      <a:r>
+                        <a:rPr lang="en-US" sz="900" u="none" strike="noStrike">
+                          <a:effectLst/>
+                        </a:rPr>
+                        <a:t>50.1</a:t>
+                      </a:r>
+                      <a:endParaRPr lang="en-US" sz="900" b="0" i="0" u="none" strike="noStrike">
+                        <a:solidFill>
+                          <a:srgbClr val="000000"/>
+                        </a:solidFill>
+                        <a:effectLst/>
+                        <a:latin typeface="Calibri" panose="020F0502020204030204" pitchFamily="34" charset="0"/>
+                      </a:endParaRPr>
+                    </a:p>
+                  </a:txBody>
+                  <a:tcPr marL="6565" marR="6565" marT="6565" marB="0" anchor="b"/>
+                </a:tc>
+                <a:tc>
+                  <a:txBody>
+                    <a:bodyPr/>
+                    <a:lstStyle/>
+                    <a:p>
+                      <a:pPr algn="r" fontAlgn="b"/>
+                      <a:r>
+                        <a:rPr lang="en-US" sz="900" u="none" strike="noStrike">
+                          <a:effectLst/>
+                        </a:rPr>
+                        <a:t>5.39</a:t>
+                      </a:r>
+                      <a:endParaRPr lang="en-US" sz="900" b="0" i="0" u="none" strike="noStrike">
+                        <a:solidFill>
+                          <a:srgbClr val="000000"/>
+                        </a:solidFill>
+                        <a:effectLst/>
+                        <a:latin typeface="Calibri" panose="020F0502020204030204" pitchFamily="34" charset="0"/>
+                      </a:endParaRPr>
+                    </a:p>
+                  </a:txBody>
+                  <a:tcPr marL="6565" marR="6565" marT="6565" marB="0" anchor="b"/>
+                </a:tc>
+                <a:tc>
+                  <a:txBody>
+                    <a:bodyPr/>
+                    <a:lstStyle/>
+                    <a:p>
+                      <a:pPr algn="r" fontAlgn="b"/>
+                      <a:r>
+                        <a:rPr lang="en-US" sz="900" u="none" strike="noStrike">
+                          <a:effectLst/>
+                        </a:rPr>
+                        <a:t>8.44</a:t>
+                      </a:r>
+                      <a:endParaRPr lang="en-US" sz="900" b="0" i="0" u="none" strike="noStrike">
+                        <a:solidFill>
+                          <a:srgbClr val="000000"/>
+                        </a:solidFill>
+                        <a:effectLst/>
+                        <a:latin typeface="Calibri" panose="020F0502020204030204" pitchFamily="34" charset="0"/>
+                      </a:endParaRPr>
+                    </a:p>
+                  </a:txBody>
+                  <a:tcPr marL="6565" marR="6565" marT="6565" marB="0" anchor="b"/>
+                </a:tc>
+                <a:tc>
+                  <a:txBody>
+                    <a:bodyPr/>
+                    <a:lstStyle/>
+                    <a:p>
+                      <a:pPr algn="r" fontAlgn="b"/>
+                      <a:r>
+                        <a:rPr lang="en-US" sz="900" u="none" strike="noStrike" dirty="0">
+                          <a:effectLst/>
+                        </a:rPr>
+                        <a:t>-3.05</a:t>
+                      </a:r>
+                      <a:endParaRPr lang="en-US" sz="900" b="0" i="0" u="none" strike="noStrike" dirty="0">
+                        <a:solidFill>
+                          <a:srgbClr val="000000"/>
+                        </a:solidFill>
+                        <a:effectLst/>
+                        <a:latin typeface="Calibri" panose="020F0502020204030204" pitchFamily="34" charset="0"/>
+                      </a:endParaRPr>
+                    </a:p>
+                  </a:txBody>
+                  <a:tcPr marL="6565" marR="6565" marT="6565" marB="0" anchor="b"/>
+                </a:tc>
+                <a:extLst>
+                  <a:ext uri="{0D108BD9-81ED-4DB2-BD59-A6C34878D82A}">
+                    <a16:rowId xmlns:a16="http://schemas.microsoft.com/office/drawing/2014/main" val="936625582"/>
+                  </a:ext>
+                </a:extLst>
+              </a:tr>
+            </a:tbl>
+          </a:graphicData>
+        </a:graphic>
+      </p:graphicFrame>
     </p:spTree>
     <p:extLst>
       <p:ext uri="{BB962C8B-B14F-4D97-AF65-F5344CB8AC3E}">
@@ -5045,116 +7924,85 @@
           <a:chExt cx="0" cy="0"/>
         </a:xfrm>
       </p:grpSpPr>
-      <p:pic>
-        <p:nvPicPr>
-          <p:cNvPr id="3" name="Picture 2">
-            <a:extLst>
-              <a:ext uri="{FF2B5EF4-FFF2-40B4-BE49-F238E27FC236}">
-                <a16:creationId xmlns:a16="http://schemas.microsoft.com/office/drawing/2014/main" id="{C11DFF7C-8DF3-4D82-8D8F-3224BE4C6CB0}"/>
-              </a:ext>
-            </a:extLst>
-          </p:cNvPr>
-          <p:cNvPicPr>
-            <a:picLocks noChangeAspect="1"/>
-          </p:cNvPicPr>
-          <p:nvPr/>
-        </p:nvPicPr>
-        <p:blipFill>
-          <a:blip r:embed="rId2"/>
-          <a:stretch>
-            <a:fillRect/>
-          </a:stretch>
-        </p:blipFill>
-        <p:spPr>
-          <a:xfrm>
-            <a:off x="892603" y="648285"/>
-            <a:ext cx="6053070" cy="3567448"/>
-          </a:xfrm>
-          <a:prstGeom prst="rect">
-            <a:avLst/>
-          </a:prstGeom>
-        </p:spPr>
-      </p:pic>
       <p:sp>
         <p:nvSpPr>
-          <p:cNvPr id="5" name="TextBox 4">
-            <a:extLst>
-              <a:ext uri="{FF2B5EF4-FFF2-40B4-BE49-F238E27FC236}">
-                <a16:creationId xmlns:a16="http://schemas.microsoft.com/office/drawing/2014/main" id="{7E2B83A9-3907-42A0-912C-AFD43AD40151}"/>
-              </a:ext>
-            </a:extLst>
-          </p:cNvPr>
-          <p:cNvSpPr txBox="1"/>
-          <p:nvPr/>
+          <p:cNvPr id="2" name="Title 1">
+            <a:extLst>
+              <a:ext uri="{FF2B5EF4-FFF2-40B4-BE49-F238E27FC236}">
+                <a16:creationId xmlns:a16="http://schemas.microsoft.com/office/drawing/2014/main" id="{F8AC62DF-433F-4A35-B42C-0D2CD983CC81}"/>
+              </a:ext>
+            </a:extLst>
+          </p:cNvPr>
+          <p:cNvSpPr>
+            <a:spLocks noGrp="1"/>
+          </p:cNvSpPr>
+          <p:nvPr>
+            <p:ph type="title"/>
+          </p:nvPr>
         </p:nvSpPr>
-        <p:spPr>
-          <a:xfrm>
-            <a:off x="3048492" y="1860815"/>
-            <a:ext cx="6096982" cy="3139321"/>
-          </a:xfrm>
-          <a:prstGeom prst="rect">
-            <a:avLst/>
-          </a:prstGeom>
-          <a:noFill/>
-        </p:spPr>
+        <p:spPr/>
         <p:txBody>
-          <a:bodyPr wrap="square">
-            <a:spAutoFit/>
-          </a:bodyPr>
+          <a:bodyPr/>
           <a:lstStyle/>
           <a:p>
             <a:r>
-              <a:rPr lang="en-US" sz="1800" b="1" i="1" u="none" strike="noStrike" baseline="0" dirty="0">
-                <a:solidFill>
-                  <a:srgbClr val="000000"/>
-                </a:solidFill>
-                <a:latin typeface="Times New Roman" panose="02020603050405020304" pitchFamily="18" charset="0"/>
-              </a:rPr>
-              <a:t>2024 Return </a:t>
-            </a:r>
-            <a:endParaRPr lang="en-US" sz="1800" b="0" i="0" u="none" strike="noStrike" baseline="0" dirty="0">
-              <a:solidFill>
-                <a:srgbClr val="000000"/>
-              </a:solidFill>
-              <a:latin typeface="Times New Roman" panose="02020603050405020304" pitchFamily="18" charset="0"/>
-            </a:endParaRPr>
-          </a:p>
-          <a:p>
-            <a:r>
-              <a:rPr lang="en-US" sz="1800" b="0" i="0" u="none" strike="noStrike" baseline="0" dirty="0">
-                <a:solidFill>
-                  <a:srgbClr val="000000"/>
-                </a:solidFill>
-                <a:latin typeface="Times New Roman" panose="02020603050405020304" pitchFamily="18" charset="0"/>
-              </a:rPr>
-              <a:t>The 2024 upriver spring Chinook return to the Columbia River totaled 116,332 adults (Tables 1 and 5) and consisted of 101,171 Age-4 fish, 14,942 Age-5 fish, and 215 Age-6 fish. The return included 70,743 (10,514 wild) adult Snake River spring/summer Chinook and 18,224 (1,609 wild) adult upper Columbia spring Chinook. The remainder of the run was destined for tributaries in the mid-Columbia area. The 2024 upriver spring Chinook return was 96% of the preseason forecast of 121,000 fish and 76% the recent 10-year average (2014–2023) of 152,289 adults. The 2024 return ranked 21</a:t>
-            </a:r>
-            <a:r>
-              <a:rPr lang="en-US" sz="1100" b="0" i="0" u="none" strike="noStrike" baseline="0" dirty="0">
-                <a:solidFill>
-                  <a:srgbClr val="000000"/>
-                </a:solidFill>
-                <a:latin typeface="Times New Roman" panose="02020603050405020304" pitchFamily="18" charset="0"/>
-              </a:rPr>
-              <a:t>st </a:t>
-            </a:r>
-            <a:r>
-              <a:rPr lang="en-US" sz="1800" b="0" i="0" u="none" strike="noStrike" baseline="0" dirty="0">
-                <a:solidFill>
-                  <a:srgbClr val="000000"/>
-                </a:solidFill>
-                <a:latin typeface="Times New Roman" panose="02020603050405020304" pitchFamily="18" charset="0"/>
-              </a:rPr>
-              <a:t>out of all returns since 1980. </a:t>
+              <a:rPr lang="en-US" dirty="0"/>
+              <a:t>explanations</a:t>
+            </a:r>
+          </a:p>
+        </p:txBody>
+      </p:sp>
+      <p:sp>
+        <p:nvSpPr>
+          <p:cNvPr id="3" name="Content Placeholder 2">
+            <a:extLst>
+              <a:ext uri="{FF2B5EF4-FFF2-40B4-BE49-F238E27FC236}">
+                <a16:creationId xmlns:a16="http://schemas.microsoft.com/office/drawing/2014/main" id="{6636E6EB-F104-4442-813A-F57FDDD26A90}"/>
+              </a:ext>
+            </a:extLst>
+          </p:cNvPr>
+          <p:cNvSpPr>
+            <a:spLocks noGrp="1"/>
+          </p:cNvSpPr>
+          <p:nvPr>
+            <p:ph idx="1"/>
+          </p:nvPr>
+        </p:nvSpPr>
+        <p:spPr/>
+        <p:txBody>
+          <a:bodyPr/>
+          <a:lstStyle/>
+          <a:p>
+            <a:r>
+              <a:rPr lang="en-US" dirty="0"/>
+              <a:t>Alt prey</a:t>
+            </a:r>
+          </a:p>
+          <a:p>
+            <a:r>
+              <a:rPr lang="en-US" dirty="0" err="1"/>
+              <a:t>Sst</a:t>
             </a:r>
             <a:endParaRPr lang="en-US" dirty="0"/>
+          </a:p>
+          <a:p>
+            <a:r>
+              <a:rPr lang="en-US" dirty="0"/>
+              <a:t>Temporal shift (sablefish recruitment vs total pop) – wrong age class</a:t>
+            </a:r>
+          </a:p>
+          <a:p>
+            <a:r>
+              <a:rPr lang="en-US" dirty="0"/>
+              <a:t>Spatial shifts</a:t>
+            </a:r>
           </a:p>
         </p:txBody>
       </p:sp>
     </p:spTree>
     <p:extLst>
       <p:ext uri="{BB962C8B-B14F-4D97-AF65-F5344CB8AC3E}">
-        <p14:creationId xmlns:p14="http://schemas.microsoft.com/office/powerpoint/2010/main" val="1901397784"/>
+        <p14:creationId xmlns:p14="http://schemas.microsoft.com/office/powerpoint/2010/main" val="2428812967"/>
       </p:ext>
     </p:extLst>
   </p:cSld>

</xml_diff>